<commit_message>
Add fiscal buffer slide: energy concentration, FX exposure, HSF
Second slide for the T&T investment deck, focused on why the fiscal
buffer matters given energy-driven FX exposure: narrowing fiscal
deficit (5.5% to 4.6% of GDP, 2026f per IMF, vs. the government's own
2.2% target), debt context (68% of GDP end-2025 vs. 27% in 2005), and
the Heritage & Stabilisation Fund (~24% of GDP, >US$6bn) shown against
a cross-country sovereign wealth fund comparison. Leaves a labeled
placeholder panel sized for the user's own Energy Institute/Wood
Mackenzie gas production chart. All figures sourced to IMF Country
Report No. 26/121 (Selected Issues, June 2026), the 2026 Article IV
Consultation, and T&T's FY2026 Budget Statement.
</commit_message>
<xml_diff>
--- a/trinidad-tobago-macro-outlook/Trinidad_Tobago_Macro_Outlook_Power_Sector.pptx
+++ b/trinidad-tobago-macro-outlook/Trinidad_Tobago_Macro_Outlook_Power_Sector.pptx
@@ -6,9 +6,10 @@
   </p:sldMasterIdLst>
   <p:sldIdLst>
     <p:sldId id="256" r:id="rId2"/>
+    <p:sldId id="257" r:id="rId3"/>
   </p:sldIdLst>
   <p:notesMasterIdLst>
-    <p:notesMasterId r:id="rId3"/>
+    <p:notesMasterId r:id="rId4"/>
   </p:notesMasterIdLst>
   <p:sldSz cx="12192000" cy="6858000"/>
   <p:notesSz cx="6858000" cy="12192000"/>
@@ -105,6 +106,653 @@
     </a:lvl9pPr>
   </p:defaultTextStyle>
 </p:presentation>
+</file>
+
+<file path=ppt/charts/chart1.xml><?xml version="1.0" encoding="utf-8"?>
+<c:chartSpace xmlns:c="http://schemas.openxmlformats.org/drawingml/2006/chart" xmlns:a="http://schemas.openxmlformats.org/drawingml/2006/main" xmlns:r="http://schemas.openxmlformats.org/officeDocument/2006/relationships">
+  <c:date1904 val="0"/>
+  <c:roundedCorners val="1"/>
+  <c:chart>
+    <c:autoTitleDeleted val="1"/>
+    <c:plotArea>
+      <c:layout/>
+      <c:barChart>
+        <c:barDir val="col"/>
+        <c:grouping val="clustered"/>
+        <c:varyColors val="0"/>
+        <c:ser>
+          <c:idx val="0"/>
+          <c:order val="0"/>
+          <c:tx>
+            <c:strRef>
+              <c:f>Sheet1!$B$1</c:f>
+              <c:strCache>
+                <c:ptCount val="1"/>
+                <c:pt idx="0">
+                  <c:v>Overall Fiscal Deficit</c:v>
+                </c:pt>
+              </c:strCache>
+            </c:strRef>
+          </c:tx>
+          <c:spPr>
+            <a:solidFill>
+              <a:srgbClr val="1B2A4A"/>
+            </a:solidFill>
+            <a:effectLst/>
+          </c:spPr>
+          <c:invertIfNegative val="0"/>
+          <c:dLbls>
+            <c:numFmt formatCode="0.0" sourceLinked="0"/>
+            <c:txPr>
+              <a:bodyPr/>
+              <a:lstStyle/>
+              <a:p>
+                <a:pPr>
+                  <a:defRPr b="0" i="0" strike="noStrike" sz="1000" u="none">
+                    <a:solidFill>
+                      <a:srgbClr val="263447"/>
+                    </a:solidFill>
+                    <a:latin typeface="Arial"/>
+                  </a:defRPr>
+                </a:pPr>
+              </a:p>
+            </c:txPr>
+            <c:showLegendKey val="0"/>
+            <c:showVal val="1"/>
+            <c:showCatName val="0"/>
+            <c:showSerName val="0"/>
+            <c:showPercent val="0"/>
+            <c:showBubbleSize val="0"/>
+            <c:showLeaderLines val="0"/>
+          </c:dLbls>
+          <c:dPt>
+            <c:idx val="0"/>
+            <c:invertIfNegative val="0"/>
+            <c:bubble3D val="0"/>
+            <c:spPr>
+              <a:solidFill>
+                <a:srgbClr val="1B2A4A"/>
+              </a:solidFill>
+              <a:effectLst/>
+            </c:spPr>
+          </c:dPt>
+          <c:dPt>
+            <c:idx val="1"/>
+            <c:invertIfNegative val="0"/>
+            <c:bubble3D val="0"/>
+            <c:spPr>
+              <a:solidFill>
+                <a:srgbClr val="1B2A4A"/>
+              </a:solidFill>
+              <a:effectLst/>
+            </c:spPr>
+          </c:dPt>
+          <c:dPt>
+            <c:idx val="2"/>
+            <c:invertIfNegative val="0"/>
+            <c:bubble3D val="0"/>
+            <c:spPr>
+              <a:solidFill>
+                <a:srgbClr val="E2A33D"/>
+              </a:solidFill>
+              <a:effectLst/>
+            </c:spPr>
+          </c:dPt>
+          <c:cat>
+            <c:multiLvlStrRef>
+              <c:f>Sheet1!$A$2:$A$4</c:f>
+              <c:multiLvlStrCache>
+                <c:ptCount val="3"/>
+                <c:lvl>
+                  <c:pt idx="0">
+                    <c:v>2025 (Actual)</c:v>
+                  </c:pt>
+                  <c:pt idx="1">
+                    <c:v>2026f (IMF)</c:v>
+                  </c:pt>
+                  <c:pt idx="2">
+                    <c:v>2026 Target (Govt.)</c:v>
+                  </c:pt>
+                </c:lvl>
+              </c:multiLvlStrCache>
+            </c:multiLvlStrRef>
+          </c:cat>
+          <c:val>
+            <c:numRef>
+              <c:f>Sheet1!$B$2:$B$4</c:f>
+              <c:numCache>
+                <c:formatCode>General</c:formatCode>
+                <c:ptCount val="3"/>
+                <c:pt idx="0">
+                  <c:v>5.5</c:v>
+                </c:pt>
+                <c:pt idx="1">
+                  <c:v>4.6</c:v>
+                </c:pt>
+                <c:pt idx="2">
+                  <c:v>2.2</c:v>
+                </c:pt>
+              </c:numCache>
+            </c:numRef>
+          </c:val>
+        </c:ser>
+        <c:dLbls>
+          <c:numFmt formatCode="0.0" sourceLinked="0"/>
+          <c:txPr>
+            <a:bodyPr/>
+            <a:lstStyle/>
+            <a:p>
+              <a:pPr>
+                <a:defRPr b="0" i="0" strike="noStrike" sz="1000" u="none">
+                  <a:solidFill>
+                    <a:srgbClr val="263447"/>
+                  </a:solidFill>
+                  <a:latin typeface="Arial"/>
+                </a:defRPr>
+              </a:pPr>
+            </a:p>
+          </c:txPr>
+          <c:showLegendKey val="0"/>
+          <c:showVal val="1"/>
+          <c:showCatName val="0"/>
+          <c:showSerName val="0"/>
+          <c:showPercent val="0"/>
+          <c:showBubbleSize val="0"/>
+          <c:showLeaderLines val="0"/>
+        </c:dLbls>
+        <c:gapWidth val="40"/>
+        <c:overlap val="0"/>
+        <c:axId val="2094734554"/>
+        <c:axId val="2094734552"/>
+        <c:axId val="2094734556"/>
+      </c:barChart>
+      <c:catAx>
+        <c:axId val="2094734554"/>
+        <c:scaling>
+          <c:orientation val="minMax"/>
+        </c:scaling>
+        <c:delete val="0"/>
+        <c:axPos val="b"/>
+        <c:numFmt formatCode="General" sourceLinked="1"/>
+        <c:majorTickMark val="out"/>
+        <c:minorTickMark val="none"/>
+        <c:tickLblPos val="low"/>
+        <c:spPr>
+          <a:ln w="12700" cap="flat">
+            <a:noFill/>
+            <a:prstDash val="solid"/>
+            <a:round/>
+          </a:ln>
+        </c:spPr>
+        <c:txPr>
+          <a:bodyPr/>
+          <a:lstStyle/>
+          <a:p>
+            <a:pPr>
+              <a:defRPr sz="950" b="0" i="0" u="none" strike="noStrike">
+                <a:solidFill>
+                  <a:srgbClr val="6B7787"/>
+                </a:solidFill>
+                <a:latin typeface="Arial"/>
+              </a:defRPr>
+            </a:pPr>
+            <a:endParaRPr lang="en-US"/>
+          </a:p>
+        </c:txPr>
+        <c:crossAx val="2094734552"/>
+        <c:crosses val="autoZero"/>
+        <c:auto val="1"/>
+        <c:lblAlgn val="ctr"/>
+        <c:noMultiLvlLbl val="1"/>
+      </c:catAx>
+      <c:valAx>
+        <c:axId val="2094734552"/>
+        <c:scaling>
+          <c:orientation val="minMax"/>
+          <c:max val="7"/>
+          <c:min val="0"/>
+        </c:scaling>
+        <c:delete val="1"/>
+        <c:axPos val="l"/>
+        <c:numFmt formatCode="General" sourceLinked="0"/>
+        <c:majorTickMark val="out"/>
+        <c:minorTickMark val="none"/>
+        <c:tickLblPos val="nextTo"/>
+        <c:spPr>
+          <a:ln w="12700" cap="flat">
+            <a:solidFill>
+              <a:srgbClr val="888888"/>
+            </a:solidFill>
+            <a:prstDash val="solid"/>
+            <a:round/>
+          </a:ln>
+        </c:spPr>
+        <c:txPr>
+          <a:bodyPr/>
+          <a:lstStyle/>
+          <a:p>
+            <a:pPr>
+              <a:defRPr sz="1200" b="0" i="0" u="none" strike="noStrike">
+                <a:solidFill>
+                  <a:srgbClr val="000000"/>
+                </a:solidFill>
+                <a:latin typeface="Arial"/>
+              </a:defRPr>
+            </a:pPr>
+            <a:endParaRPr lang="en-US"/>
+          </a:p>
+        </c:txPr>
+        <c:crossAx val="2094734554"/>
+        <c:crosses val="autoZero"/>
+        <c:crossBetween val="between"/>
+      </c:valAx>
+      <c:spPr>
+        <a:noFill/>
+        <a:ln>
+          <a:noFill/>
+        </a:ln>
+        <a:effectLst/>
+      </c:spPr>
+    </c:plotArea>
+    <c:plotVisOnly val="1"/>
+    <c:dispBlanksAs val="span"/>
+  </c:chart>
+  <c:spPr>
+    <a:solidFill>
+      <a:srgbClr val="FFFFFF"/>
+    </a:solidFill>
+    <a:ln>
+      <a:noFill/>
+    </a:ln>
+    <a:effectLst/>
+  </c:spPr>
+  <c:externalData r:id="rId1">
+    <c:autoUpdate val="0"/>
+  </c:externalData>
+</c:chartSpace>
+</file>
+
+<file path=ppt/charts/chart2.xml><?xml version="1.0" encoding="utf-8"?>
+<c:chartSpace xmlns:c="http://schemas.openxmlformats.org/drawingml/2006/chart" xmlns:a="http://schemas.openxmlformats.org/drawingml/2006/main" xmlns:r="http://schemas.openxmlformats.org/officeDocument/2006/relationships">
+  <c:date1904 val="0"/>
+  <c:roundedCorners val="1"/>
+  <c:chart>
+    <c:autoTitleDeleted val="1"/>
+    <c:plotArea>
+      <c:layout/>
+      <c:barChart>
+        <c:barDir val="col"/>
+        <c:grouping val="clustered"/>
+        <c:varyColors val="0"/>
+        <c:ser>
+          <c:idx val="0"/>
+          <c:order val="0"/>
+          <c:tx>
+            <c:strRef>
+              <c:f>Sheet1!$B$1</c:f>
+              <c:strCache>
+                <c:ptCount val="1"/>
+                <c:pt idx="0">
+                  <c:v>SWF Assets % of GDP (2024)</c:v>
+                </c:pt>
+              </c:strCache>
+            </c:strRef>
+          </c:tx>
+          <c:spPr>
+            <a:solidFill>
+              <a:srgbClr val="9AA7B8"/>
+            </a:solidFill>
+            <a:effectLst/>
+          </c:spPr>
+          <c:invertIfNegative val="0"/>
+          <c:dLbls>
+            <c:numFmt formatCode="0.0" sourceLinked="0"/>
+            <c:txPr>
+              <a:bodyPr/>
+              <a:lstStyle/>
+              <a:p>
+                <a:pPr>
+                  <a:defRPr b="0" i="0" strike="noStrike" sz="850" u="none">
+                    <a:solidFill>
+                      <a:srgbClr val="263447"/>
+                    </a:solidFill>
+                    <a:latin typeface="Arial"/>
+                  </a:defRPr>
+                </a:pPr>
+              </a:p>
+            </c:txPr>
+            <c:showLegendKey val="0"/>
+            <c:showVal val="1"/>
+            <c:showCatName val="0"/>
+            <c:showSerName val="0"/>
+            <c:showPercent val="0"/>
+            <c:showBubbleSize val="0"/>
+            <c:showLeaderLines val="0"/>
+          </c:dLbls>
+          <c:dPt>
+            <c:idx val="0"/>
+            <c:invertIfNegative val="0"/>
+            <c:bubble3D val="0"/>
+            <c:spPr>
+              <a:solidFill>
+                <a:srgbClr val="9AA7B8"/>
+              </a:solidFill>
+              <a:effectLst/>
+            </c:spPr>
+          </c:dPt>
+          <c:dPt>
+            <c:idx val="1"/>
+            <c:invertIfNegative val="0"/>
+            <c:bubble3D val="0"/>
+            <c:spPr>
+              <a:solidFill>
+                <a:srgbClr val="E2A33D"/>
+              </a:solidFill>
+              <a:effectLst/>
+            </c:spPr>
+          </c:dPt>
+          <c:dPt>
+            <c:idx val="2"/>
+            <c:invertIfNegative val="0"/>
+            <c:bubble3D val="0"/>
+            <c:spPr>
+              <a:solidFill>
+                <a:srgbClr val="9AA7B8"/>
+              </a:solidFill>
+              <a:effectLst/>
+            </c:spPr>
+          </c:dPt>
+          <c:dPt>
+            <c:idx val="3"/>
+            <c:invertIfNegative val="0"/>
+            <c:bubble3D val="0"/>
+            <c:spPr>
+              <a:solidFill>
+                <a:srgbClr val="9AA7B8"/>
+              </a:solidFill>
+              <a:effectLst/>
+            </c:spPr>
+          </c:dPt>
+          <c:dPt>
+            <c:idx val="4"/>
+            <c:invertIfNegative val="0"/>
+            <c:bubble3D val="0"/>
+            <c:spPr>
+              <a:solidFill>
+                <a:srgbClr val="9AA7B8"/>
+              </a:solidFill>
+              <a:effectLst/>
+            </c:spPr>
+          </c:dPt>
+          <c:dPt>
+            <c:idx val="5"/>
+            <c:invertIfNegative val="0"/>
+            <c:bubble3D val="0"/>
+            <c:spPr>
+              <a:solidFill>
+                <a:srgbClr val="9AA7B8"/>
+              </a:solidFill>
+              <a:effectLst/>
+            </c:spPr>
+          </c:dPt>
+          <c:dPt>
+            <c:idx val="6"/>
+            <c:invertIfNegative val="0"/>
+            <c:bubble3D val="0"/>
+            <c:spPr>
+              <a:solidFill>
+                <a:srgbClr val="9AA7B8"/>
+              </a:solidFill>
+              <a:effectLst/>
+            </c:spPr>
+          </c:dPt>
+          <c:dPt>
+            <c:idx val="7"/>
+            <c:invertIfNegative val="0"/>
+            <c:bubble3D val="0"/>
+            <c:spPr>
+              <a:solidFill>
+                <a:srgbClr val="9AA7B8"/>
+              </a:solidFill>
+              <a:effectLst/>
+            </c:spPr>
+          </c:dPt>
+          <c:dPt>
+            <c:idx val="8"/>
+            <c:invertIfNegative val="0"/>
+            <c:bubble3D val="0"/>
+            <c:spPr>
+              <a:solidFill>
+                <a:srgbClr val="9AA7B8"/>
+              </a:solidFill>
+              <a:effectLst/>
+            </c:spPr>
+          </c:dPt>
+          <c:dPt>
+            <c:idx val="9"/>
+            <c:invertIfNegative val="0"/>
+            <c:bubble3D val="0"/>
+            <c:spPr>
+              <a:solidFill>
+                <a:srgbClr val="9AA7B8"/>
+              </a:solidFill>
+              <a:effectLst/>
+            </c:spPr>
+          </c:dPt>
+          <c:cat>
+            <c:multiLvlStrRef>
+              <c:f>Sheet1!$A$2:$A$11</c:f>
+              <c:multiLvlStrCache>
+                <c:ptCount val="10"/>
+                <c:lvl>
+                  <c:pt idx="0">
+                    <c:v>CHN</c:v>
+                  </c:pt>
+                  <c:pt idx="1">
+                    <c:v>TTO</c:v>
+                  </c:pt>
+                  <c:pt idx="2">
+                    <c:v>IDN</c:v>
+                  </c:pt>
+                  <c:pt idx="3">
+                    <c:v>SAU</c:v>
+                  </c:pt>
+                  <c:pt idx="4">
+                    <c:v>HKG</c:v>
+                  </c:pt>
+                  <c:pt idx="5">
+                    <c:v>SGP</c:v>
+                  </c:pt>
+                  <c:pt idx="6">
+                    <c:v>ARE</c:v>
+                  </c:pt>
+                  <c:pt idx="7">
+                    <c:v>QAT</c:v>
+                  </c:pt>
+                  <c:pt idx="8">
+                    <c:v>NOR</c:v>
+                  </c:pt>
+                  <c:pt idx="9">
+                    <c:v>KWT</c:v>
+                  </c:pt>
+                </c:lvl>
+              </c:multiLvlStrCache>
+            </c:multiLvlStrRef>
+          </c:cat>
+          <c:val>
+            <c:numRef>
+              <c:f>Sheet1!$B$2:$B$11</c:f>
+              <c:numCache>
+                <c:formatCode>General</c:formatCode>
+                <c:ptCount val="10"/>
+                <c:pt idx="0">
+                  <c:v>18.8</c:v>
+                </c:pt>
+                <c:pt idx="1">
+                  <c:v>24.7</c:v>
+                </c:pt>
+                <c:pt idx="2">
+                  <c:v>64.5</c:v>
+                </c:pt>
+                <c:pt idx="3">
+                  <c:v>74.6</c:v>
+                </c:pt>
+                <c:pt idx="4">
+                  <c:v>131.1</c:v>
+                </c:pt>
+                <c:pt idx="5">
+                  <c:v>171</c:v>
+                </c:pt>
+                <c:pt idx="6">
+                  <c:v>204.4</c:v>
+                </c:pt>
+                <c:pt idx="7">
+                  <c:v>254.1</c:v>
+                </c:pt>
+                <c:pt idx="8">
+                  <c:v>437.9</c:v>
+                </c:pt>
+                <c:pt idx="9">
+                  <c:v>642.2</c:v>
+                </c:pt>
+              </c:numCache>
+            </c:numRef>
+          </c:val>
+        </c:ser>
+        <c:dLbls>
+          <c:numFmt formatCode="0.0" sourceLinked="0"/>
+          <c:txPr>
+            <a:bodyPr/>
+            <a:lstStyle/>
+            <a:p>
+              <a:pPr>
+                <a:defRPr b="0" i="0" strike="noStrike" sz="850" u="none">
+                  <a:solidFill>
+                    <a:srgbClr val="263447"/>
+                  </a:solidFill>
+                  <a:latin typeface="Arial"/>
+                </a:defRPr>
+              </a:pPr>
+            </a:p>
+          </c:txPr>
+          <c:showLegendKey val="0"/>
+          <c:showVal val="1"/>
+          <c:showCatName val="0"/>
+          <c:showSerName val="0"/>
+          <c:showPercent val="0"/>
+          <c:showBubbleSize val="0"/>
+          <c:showLeaderLines val="0"/>
+        </c:dLbls>
+        <c:gapWidth val="30"/>
+        <c:overlap val="0"/>
+        <c:axId val="2094734554"/>
+        <c:axId val="2094734552"/>
+        <c:axId val="2094734556"/>
+      </c:barChart>
+      <c:catAx>
+        <c:axId val="2094734554"/>
+        <c:scaling>
+          <c:orientation val="minMax"/>
+        </c:scaling>
+        <c:delete val="0"/>
+        <c:axPos val="b"/>
+        <c:numFmt formatCode="General" sourceLinked="1"/>
+        <c:majorTickMark val="out"/>
+        <c:minorTickMark val="none"/>
+        <c:tickLblPos val="low"/>
+        <c:spPr>
+          <a:ln w="12700" cap="flat">
+            <a:noFill/>
+            <a:prstDash val="solid"/>
+            <a:round/>
+          </a:ln>
+        </c:spPr>
+        <c:txPr>
+          <a:bodyPr/>
+          <a:lstStyle/>
+          <a:p>
+            <a:pPr>
+              <a:defRPr sz="900" b="0" i="0" u="none" strike="noStrike">
+                <a:solidFill>
+                  <a:srgbClr val="6B7787"/>
+                </a:solidFill>
+                <a:latin typeface="Arial"/>
+              </a:defRPr>
+            </a:pPr>
+            <a:endParaRPr lang="en-US"/>
+          </a:p>
+        </c:txPr>
+        <c:crossAx val="2094734552"/>
+        <c:crosses val="autoZero"/>
+        <c:auto val="1"/>
+        <c:lblAlgn val="ctr"/>
+        <c:noMultiLvlLbl val="1"/>
+      </c:catAx>
+      <c:valAx>
+        <c:axId val="2094734552"/>
+        <c:scaling>
+          <c:orientation val="minMax"/>
+          <c:max val="700"/>
+          <c:min val="0"/>
+        </c:scaling>
+        <c:delete val="1"/>
+        <c:axPos val="l"/>
+        <c:numFmt formatCode="General" sourceLinked="0"/>
+        <c:majorTickMark val="out"/>
+        <c:minorTickMark val="none"/>
+        <c:tickLblPos val="nextTo"/>
+        <c:spPr>
+          <a:ln w="12700" cap="flat">
+            <a:solidFill>
+              <a:srgbClr val="888888"/>
+            </a:solidFill>
+            <a:prstDash val="solid"/>
+            <a:round/>
+          </a:ln>
+        </c:spPr>
+        <c:txPr>
+          <a:bodyPr/>
+          <a:lstStyle/>
+          <a:p>
+            <a:pPr>
+              <a:defRPr sz="1200" b="0" i="0" u="none" strike="noStrike">
+                <a:solidFill>
+                  <a:srgbClr val="000000"/>
+                </a:solidFill>
+                <a:latin typeface="Arial"/>
+              </a:defRPr>
+            </a:pPr>
+            <a:endParaRPr lang="en-US"/>
+          </a:p>
+        </c:txPr>
+        <c:crossAx val="2094734554"/>
+        <c:crosses val="autoZero"/>
+        <c:crossBetween val="between"/>
+      </c:valAx>
+      <c:spPr>
+        <a:noFill/>
+        <a:ln>
+          <a:noFill/>
+        </a:ln>
+        <a:effectLst/>
+      </c:spPr>
+    </c:plotArea>
+    <c:plotVisOnly val="1"/>
+    <c:dispBlanksAs val="span"/>
+  </c:chart>
+  <c:spPr>
+    <a:solidFill>
+      <a:srgbClr val="FFFFFF"/>
+    </a:solidFill>
+    <a:ln>
+      <a:noFill/>
+    </a:ln>
+    <a:effectLst/>
+  </c:spPr>
+  <c:externalData r:id="rId1">
+    <c:autoUpdate val="0"/>
+  </c:externalData>
+</c:chartSpace>
 </file>
 
 <file path=ppt/notesMasters/notesMaster1.xml><?xml version="1.0" encoding="utf-8"?>
@@ -526,6 +1174,94 @@
             <a:fld id="{F7021451-1387-4CA6-816F-3879F97B5CBC}" type="slidenum">
               <a:rPr lang="en-US"/>
               <a:t>1</a:t>
+            </a:fld>
+            <a:endParaRPr lang="en-US"/>
+          </a:p>
+        </p:txBody>
+      </p:sp>
+    </p:spTree>
+    <p:extLst>
+      <p:ext uri="{BB962C8B-B14F-4D97-AF65-F5344CB8AC3E}">
+        <p14:creationId xmlns:p14="http://schemas.microsoft.com/office/powerpoint/2010/main" val="1024086991"/>
+      </p:ext>
+    </p:extLst>
+  </p:cSld>
+  <p:clrMapOvr>
+    <a:masterClrMapping/>
+  </p:clrMapOvr>
+</p:notes>
+</file>
+
+<file path=ppt/notesSlides/notesSlide2.xml><?xml version="1.0" encoding="utf-8"?>
+<p:notes xmlns:a="http://schemas.openxmlformats.org/drawingml/2006/main" xmlns:r="http://schemas.openxmlformats.org/officeDocument/2006/relationships" xmlns:p="http://schemas.openxmlformats.org/presentationml/2006/main">
+  <p:cSld>
+    <p:spTree>
+      <p:nvGrpSpPr>
+        <p:cNvPr id="1" name=""/>
+        <p:cNvGrpSpPr/>
+        <p:nvPr/>
+      </p:nvGrpSpPr>
+      <p:grpSpPr>
+        <a:xfrm>
+          <a:off x="0" y="0"/>
+          <a:ext cx="0" cy="0"/>
+          <a:chOff x="0" y="0"/>
+          <a:chExt cx="0" cy="0"/>
+        </a:xfrm>
+      </p:grpSpPr>
+      <p:sp>
+        <p:nvSpPr>
+          <p:cNvPr id="2" name="Slide Image Placeholder 1"/>
+          <p:cNvSpPr>
+            <a:spLocks noGrp="1" noRot="1" noChangeAspect="1"/>
+          </p:cNvSpPr>
+          <p:nvPr>
+            <p:ph type="sldImg"/>
+          </p:nvPr>
+        </p:nvSpPr>
+        <p:spPr/>
+      </p:sp>
+      <p:sp>
+        <p:nvSpPr>
+          <p:cNvPr id="3" name="Notes Placeholder 2"/>
+          <p:cNvSpPr>
+            <a:spLocks noGrp="1"/>
+          </p:cNvSpPr>
+          <p:nvPr>
+            <p:ph type="body" idx="1"/>
+          </p:nvPr>
+        </p:nvSpPr>
+        <p:spPr/>
+        <p:txBody>
+          <a:bodyPr/>
+          <a:lstStyle/>
+          <a:p>
+            <a:r>
+              <a:rPr lang="en-US" dirty="0"/>
+              <a:t/>
+            </a:r>
+            <a:endParaRPr lang="en-US" dirty="0"/>
+          </a:p>
+        </p:txBody>
+      </p:sp>
+      <p:sp>
+        <p:nvSpPr>
+          <p:cNvPr id="4" name="Slide Number Placeholder 3"/>
+          <p:cNvSpPr>
+            <a:spLocks noGrp="1"/>
+          </p:cNvSpPr>
+          <p:nvPr>
+            <p:ph type="sldNum" sz="quarter" idx="10"/>
+          </p:nvPr>
+        </p:nvSpPr>
+        <p:spPr/>
+        <p:txBody>
+          <a:bodyPr/>
+          <a:lstStyle/>
+          <a:p>
+            <a:fld id="{F7021451-1387-4CA6-816F-3879F97B5CBC}" type="slidenum">
+              <a:rPr lang="en-US"/>
+              <a:t>2</a:t>
             </a:fld>
             <a:endParaRPr lang="en-US"/>
           </a:p>
@@ -883,7 +1619,7 @@
         </p:nvSpPr>
         <p:spPr>
           <a:xfrm>
-            <a:off x="457200" y="274320"/>
+            <a:off x="457200" y="256032"/>
             <a:ext cx="8229600" cy="530352"/>
           </a:xfrm>
           <a:prstGeom prst="rect">
@@ -922,8 +1658,8 @@
         </p:nvSpPr>
         <p:spPr>
           <a:xfrm>
-            <a:off x="457200" y="822960"/>
-            <a:ext cx="9509760" cy="329184"/>
+            <a:off x="457200" y="795528"/>
+            <a:ext cx="9692640" cy="329184"/>
           </a:xfrm>
           <a:prstGeom prst="rect">
             <a:avLst/>
@@ -961,8 +1697,8 @@
         </p:nvSpPr>
         <p:spPr>
           <a:xfrm>
-            <a:off x="457200" y="1161288"/>
-            <a:ext cx="7315200" cy="228600"/>
+            <a:off x="457200" y="1124712"/>
+            <a:ext cx="7315200" cy="219456"/>
           </a:xfrm>
           <a:prstGeom prst="rect">
             <a:avLst/>
@@ -1000,7 +1736,7 @@
         </p:nvSpPr>
         <p:spPr>
           <a:xfrm>
-            <a:off x="10863072" y="256032"/>
+            <a:off x="10863072" y="237744"/>
             <a:ext cx="841248" cy="841248"/>
           </a:xfrm>
           <a:prstGeom prst="ellipse">
@@ -1028,7 +1764,7 @@
         </p:blipFill>
         <p:spPr>
           <a:xfrm>
-            <a:off x="11105388" y="498348"/>
+            <a:off x="11105388" y="480060"/>
             <a:ext cx="356616" cy="356616"/>
           </a:xfrm>
           <a:prstGeom prst="rect">
@@ -1045,11 +1781,11 @@
         <p:spPr>
           <a:xfrm>
             <a:off x="457200" y="1572768"/>
-            <a:ext cx="2109155" cy="960120"/>
+            <a:ext cx="2109155" cy="914400"/>
           </a:xfrm>
           <a:prstGeom prst="roundRect">
             <a:avLst>
-              <a:gd name="adj" fmla="val 7619"/>
+              <a:gd name="adj" fmla="val 8000"/>
             </a:avLst>
           </a:prstGeom>
           <a:solidFill>
@@ -1073,8 +1809,8 @@
         </p:nvSpPr>
         <p:spPr>
           <a:xfrm>
-            <a:off x="457200" y="1673352"/>
-            <a:ext cx="2109155" cy="420624"/>
+            <a:off x="457200" y="1664208"/>
+            <a:ext cx="2109155" cy="402336"/>
           </a:xfrm>
           <a:prstGeom prst="rect">
             <a:avLst/>
@@ -1090,7 +1826,7 @@
               <a:buNone/>
             </a:pPr>
             <a:r>
-              <a:rPr lang="en-US" sz="2200" b="1" dirty="0">
+              <a:rPr lang="en-US" sz="2100" b="1" dirty="0">
                 <a:solidFill>
                   <a:srgbClr val="E2A33D"/>
                 </a:solidFill>
@@ -1100,7 +1836,7 @@
               </a:rPr>
               <a:t>0.8%</a:t>
             </a:r>
-            <a:endParaRPr lang="en-US" sz="2200" dirty="0"/>
+            <a:endParaRPr lang="en-US" sz="2100" dirty="0"/>
           </a:p>
         </p:txBody>
       </p:sp>
@@ -1112,8 +1848,8 @@
         </p:nvSpPr>
         <p:spPr>
           <a:xfrm>
-            <a:off x="512064" y="2103120"/>
-            <a:ext cx="1999427" cy="402336"/>
+            <a:off x="512064" y="2075688"/>
+            <a:ext cx="1999427" cy="384048"/>
           </a:xfrm>
           <a:prstGeom prst="rect">
             <a:avLst/>
@@ -1152,11 +1888,11 @@
         <p:spPr>
           <a:xfrm>
             <a:off x="2749235" y="1572768"/>
-            <a:ext cx="2109155" cy="960120"/>
+            <a:ext cx="2109155" cy="914400"/>
           </a:xfrm>
           <a:prstGeom prst="roundRect">
             <a:avLst>
-              <a:gd name="adj" fmla="val 7619"/>
+              <a:gd name="adj" fmla="val 8000"/>
             </a:avLst>
           </a:prstGeom>
           <a:solidFill>
@@ -1180,8 +1916,8 @@
         </p:nvSpPr>
         <p:spPr>
           <a:xfrm>
-            <a:off x="2749235" y="1673352"/>
-            <a:ext cx="2109155" cy="420624"/>
+            <a:off x="2749235" y="1664208"/>
+            <a:ext cx="2109155" cy="402336"/>
           </a:xfrm>
           <a:prstGeom prst="rect">
             <a:avLst/>
@@ -1197,7 +1933,7 @@
               <a:buNone/>
             </a:pPr>
             <a:r>
-              <a:rPr lang="en-US" sz="2200" b="1" dirty="0">
+              <a:rPr lang="en-US" sz="2100" b="1" dirty="0">
                 <a:solidFill>
                   <a:srgbClr val="E2A33D"/>
                 </a:solidFill>
@@ -1207,7 +1943,7 @@
               </a:rPr>
               <a:t>4.6%</a:t>
             </a:r>
-            <a:endParaRPr lang="en-US" sz="2200" dirty="0"/>
+            <a:endParaRPr lang="en-US" sz="2100" dirty="0"/>
           </a:p>
         </p:txBody>
       </p:sp>
@@ -1219,8 +1955,8 @@
         </p:nvSpPr>
         <p:spPr>
           <a:xfrm>
-            <a:off x="2804099" y="2103120"/>
-            <a:ext cx="1999427" cy="402336"/>
+            <a:off x="2804099" y="2075688"/>
+            <a:ext cx="1999427" cy="384048"/>
           </a:xfrm>
           <a:prstGeom prst="rect">
             <a:avLst/>
@@ -1259,11 +1995,11 @@
         <p:spPr>
           <a:xfrm>
             <a:off x="5041270" y="1572768"/>
-            <a:ext cx="2109155" cy="960120"/>
+            <a:ext cx="2109155" cy="914400"/>
           </a:xfrm>
           <a:prstGeom prst="roundRect">
             <a:avLst>
-              <a:gd name="adj" fmla="val 7619"/>
+              <a:gd name="adj" fmla="val 8000"/>
             </a:avLst>
           </a:prstGeom>
           <a:solidFill>
@@ -1287,8 +2023,8 @@
         </p:nvSpPr>
         <p:spPr>
           <a:xfrm>
-            <a:off x="5041270" y="1673352"/>
-            <a:ext cx="2109155" cy="420624"/>
+            <a:off x="5041270" y="1664208"/>
+            <a:ext cx="2109155" cy="402336"/>
           </a:xfrm>
           <a:prstGeom prst="rect">
             <a:avLst/>
@@ -1304,7 +2040,7 @@
               <a:buNone/>
             </a:pPr>
             <a:r>
-              <a:rPr lang="en-US" sz="2200" b="1" dirty="0">
+              <a:rPr lang="en-US" sz="2100" b="1" dirty="0">
                 <a:solidFill>
                   <a:srgbClr val="E2A33D"/>
                 </a:solidFill>
@@ -1314,7 +2050,7 @@
               </a:rPr>
               <a:t>BBB-</a:t>
             </a:r>
-            <a:endParaRPr lang="en-US" sz="2200" dirty="0"/>
+            <a:endParaRPr lang="en-US" sz="2100" dirty="0"/>
           </a:p>
         </p:txBody>
       </p:sp>
@@ -1326,8 +2062,8 @@
         </p:nvSpPr>
         <p:spPr>
           <a:xfrm>
-            <a:off x="5096134" y="2103120"/>
-            <a:ext cx="1999427" cy="402336"/>
+            <a:off x="5096134" y="2075688"/>
+            <a:ext cx="1999427" cy="384048"/>
           </a:xfrm>
           <a:prstGeom prst="rect">
             <a:avLst/>
@@ -1366,11 +2102,11 @@
         <p:spPr>
           <a:xfrm>
             <a:off x="7333305" y="1572768"/>
-            <a:ext cx="2109155" cy="960120"/>
+            <a:ext cx="2109155" cy="914400"/>
           </a:xfrm>
           <a:prstGeom prst="roundRect">
             <a:avLst>
-              <a:gd name="adj" fmla="val 7619"/>
+              <a:gd name="adj" fmla="val 8000"/>
             </a:avLst>
           </a:prstGeom>
           <a:solidFill>
@@ -1394,8 +2130,8 @@
         </p:nvSpPr>
         <p:spPr>
           <a:xfrm>
-            <a:off x="7333305" y="1673352"/>
-            <a:ext cx="2109155" cy="420624"/>
+            <a:off x="7333305" y="1664208"/>
+            <a:ext cx="2109155" cy="402336"/>
           </a:xfrm>
           <a:prstGeom prst="rect">
             <a:avLst/>
@@ -1411,7 +2147,7 @@
               <a:buNone/>
             </a:pPr>
             <a:r>
-              <a:rPr lang="en-US" sz="2200" b="1" dirty="0">
+              <a:rPr lang="en-US" sz="2100" b="1" dirty="0">
                 <a:solidFill>
                   <a:srgbClr val="E2A33D"/>
                 </a:solidFill>
@@ -1421,7 +2157,7 @@
               </a:rPr>
               <a:t>20%</a:t>
             </a:r>
-            <a:endParaRPr lang="en-US" sz="2200" dirty="0"/>
+            <a:endParaRPr lang="en-US" sz="2100" dirty="0"/>
           </a:p>
         </p:txBody>
       </p:sp>
@@ -1433,8 +2169,8 @@
         </p:nvSpPr>
         <p:spPr>
           <a:xfrm>
-            <a:off x="7388169" y="2103120"/>
-            <a:ext cx="1999427" cy="402336"/>
+            <a:off x="7388169" y="2075688"/>
+            <a:ext cx="1999427" cy="384048"/>
           </a:xfrm>
           <a:prstGeom prst="rect">
             <a:avLst/>
@@ -1473,11 +2209,11 @@
         <p:spPr>
           <a:xfrm>
             <a:off x="9625340" y="1572768"/>
-            <a:ext cx="2109155" cy="960120"/>
+            <a:ext cx="2109155" cy="914400"/>
           </a:xfrm>
           <a:prstGeom prst="roundRect">
             <a:avLst>
-              <a:gd name="adj" fmla="val 7619"/>
+              <a:gd name="adj" fmla="val 8000"/>
             </a:avLst>
           </a:prstGeom>
           <a:solidFill>
@@ -1501,8 +2237,8 @@
         </p:nvSpPr>
         <p:spPr>
           <a:xfrm>
-            <a:off x="9625340" y="1673352"/>
-            <a:ext cx="2109155" cy="420624"/>
+            <a:off x="9625340" y="1664208"/>
+            <a:ext cx="2109155" cy="402336"/>
           </a:xfrm>
           <a:prstGeom prst="rect">
             <a:avLst/>
@@ -1518,7 +2254,7 @@
               <a:buNone/>
             </a:pPr>
             <a:r>
-              <a:rPr lang="en-US" sz="2200" b="1" dirty="0">
+              <a:rPr lang="en-US" sz="2100" b="1" dirty="0">
                 <a:solidFill>
                   <a:srgbClr val="E2A33D"/>
                 </a:solidFill>
@@ -1528,7 +2264,7 @@
               </a:rPr>
               <a:t>92 MW</a:t>
             </a:r>
-            <a:endParaRPr lang="en-US" sz="2200" dirty="0"/>
+            <a:endParaRPr lang="en-US" sz="2100" dirty="0"/>
           </a:p>
         </p:txBody>
       </p:sp>
@@ -1540,8 +2276,8 @@
         </p:nvSpPr>
         <p:spPr>
           <a:xfrm>
-            <a:off x="9680204" y="2103120"/>
-            <a:ext cx="1999427" cy="402336"/>
+            <a:off x="9680204" y="2075688"/>
+            <a:ext cx="1999427" cy="384048"/>
           </a:xfrm>
           <a:prstGeom prst="rect">
             <a:avLst/>
@@ -2232,6 +2968,1219 @@
                 <a:cs typeface="Calibri" pitchFamily="34" charset="-120"/>
               </a:rPr>
               <a:t>Sources: IMF, Trinidad and Tobago — 2026 Article IV Consultation (Staff Concluding Statement, Feb 2026) and Country Report No. 26/121, Selected Issues (June 2026); S&amp;P Global Ratings sovereign rating actions (2025–26); T&amp;T Ministry of Energy and Energy Industries.</a:t>
+            </a:r>
+            <a:endParaRPr lang="en-US" sz="800" dirty="0"/>
+          </a:p>
+        </p:txBody>
+      </p:sp>
+    </p:spTree>
+  </p:cSld>
+  <p:clrMapOvr>
+    <a:masterClrMapping/>
+  </p:clrMapOvr>
+</p:sld>
+</file>
+
+<file path=ppt/slides/slide2.xml><?xml version="1.0" encoding="utf-8"?>
+<p:sld xmlns:a="http://schemas.openxmlformats.org/drawingml/2006/main" xmlns:r="http://schemas.openxmlformats.org/officeDocument/2006/relationships" xmlns:p="http://schemas.openxmlformats.org/presentationml/2006/main">
+  <p:cSld name="Slide 2">
+    <p:bg>
+      <p:bgPr>
+        <a:solidFill>
+          <a:srgbClr val="FFFFFF"/>
+        </a:solidFill>
+      </p:bgPr>
+    </p:bg>
+    <p:spTree>
+      <p:nvGrpSpPr>
+        <p:cNvPr id="1" name=""/>
+        <p:cNvGrpSpPr/>
+        <p:nvPr/>
+      </p:nvGrpSpPr>
+      <p:grpSpPr>
+        <a:xfrm>
+          <a:off x="0" y="0"/>
+          <a:ext cx="0" cy="0"/>
+          <a:chOff x="0" y="0"/>
+          <a:chExt cx="0" cy="0"/>
+        </a:xfrm>
+      </p:grpSpPr>
+      <p:sp>
+        <p:nvSpPr>
+          <p:cNvPr id="2" name="Text 0"/>
+          <p:cNvSpPr/>
+          <p:nvPr/>
+        </p:nvSpPr>
+        <p:spPr>
+          <a:xfrm>
+            <a:off x="457200" y="256032"/>
+            <a:ext cx="8229600" cy="530352"/>
+          </a:xfrm>
+          <a:prstGeom prst="rect">
+            <a:avLst/>
+          </a:prstGeom>
+          <a:noFill/>
+          <a:ln/>
+        </p:spPr>
+        <p:txBody>
+          <a:bodyPr wrap="square" lIns="0" tIns="0" rIns="0" bIns="0" rtlCol="0" anchor="ctr"/>
+          <a:lstStyle/>
+          <a:p>
+            <a:pPr indent="0" marL="0">
+              <a:buNone/>
+            </a:pPr>
+            <a:r>
+              <a:rPr lang="en-US" sz="3300" b="1" dirty="0">
+                <a:solidFill>
+                  <a:srgbClr val="1B2A4A"/>
+                </a:solidFill>
+                <a:latin typeface="Calibri" pitchFamily="34" charset="0"/>
+                <a:ea typeface="Calibri" pitchFamily="34" charset="-122"/>
+                <a:cs typeface="Calibri" pitchFamily="34" charset="-120"/>
+              </a:rPr>
+              <a:t>Trinidad &amp; Tobago</a:t>
+            </a:r>
+            <a:endParaRPr lang="en-US" sz="3300" dirty="0"/>
+          </a:p>
+        </p:txBody>
+      </p:sp>
+      <p:sp>
+        <p:nvSpPr>
+          <p:cNvPr id="3" name="Text 1"/>
+          <p:cNvSpPr/>
+          <p:nvPr/>
+        </p:nvSpPr>
+        <p:spPr>
+          <a:xfrm>
+            <a:off x="457200" y="795528"/>
+            <a:ext cx="9692640" cy="329184"/>
+          </a:xfrm>
+          <a:prstGeom prst="rect">
+            <a:avLst/>
+          </a:prstGeom>
+          <a:noFill/>
+          <a:ln/>
+        </p:spPr>
+        <p:txBody>
+          <a:bodyPr wrap="square" lIns="0" tIns="0" rIns="0" bIns="0" rtlCol="0" anchor="ctr"/>
+          <a:lstStyle/>
+          <a:p>
+            <a:pPr indent="0" marL="0">
+              <a:buNone/>
+            </a:pPr>
+            <a:r>
+              <a:rPr lang="en-US" sz="1550" dirty="0">
+                <a:solidFill>
+                  <a:srgbClr val="263447"/>
+                </a:solidFill>
+                <a:latin typeface="Calibri" pitchFamily="34" charset="0"/>
+                <a:ea typeface="Calibri" pitchFamily="34" charset="-122"/>
+                <a:cs typeface="Calibri" pitchFamily="34" charset="-120"/>
+              </a:rPr>
+              <a:t>Energy Concentration, FX Exposure &amp; the Fiscal Buffer</a:t>
+            </a:r>
+            <a:endParaRPr lang="en-US" sz="1550" dirty="0"/>
+          </a:p>
+        </p:txBody>
+      </p:sp>
+      <p:sp>
+        <p:nvSpPr>
+          <p:cNvPr id="4" name="Text 2"/>
+          <p:cNvSpPr/>
+          <p:nvPr/>
+        </p:nvSpPr>
+        <p:spPr>
+          <a:xfrm>
+            <a:off x="457200" y="1124712"/>
+            <a:ext cx="7315200" cy="219456"/>
+          </a:xfrm>
+          <a:prstGeom prst="rect">
+            <a:avLst/>
+          </a:prstGeom>
+          <a:noFill/>
+          <a:ln/>
+        </p:spPr>
+        <p:txBody>
+          <a:bodyPr wrap="square" lIns="0" tIns="0" rIns="0" bIns="0" rtlCol="0" anchor="ctr"/>
+          <a:lstStyle/>
+          <a:p>
+            <a:pPr indent="0" marL="0">
+              <a:buNone/>
+            </a:pPr>
+            <a:r>
+              <a:rPr lang="en-US" sz="1050" i="1" dirty="0">
+                <a:solidFill>
+                  <a:srgbClr val="6B7787"/>
+                </a:solidFill>
+                <a:latin typeface="Calibri" pitchFamily="34" charset="0"/>
+                <a:ea typeface="Calibri" pitchFamily="34" charset="-122"/>
+                <a:cs typeface="Calibri" pitchFamily="34" charset="-120"/>
+              </a:rPr>
+              <a:t>Prepared for investment opportunity assessment  |  August 2026</a:t>
+            </a:r>
+            <a:endParaRPr lang="en-US" sz="1050" dirty="0"/>
+          </a:p>
+        </p:txBody>
+      </p:sp>
+      <p:sp>
+        <p:nvSpPr>
+          <p:cNvPr id="5" name="Shape 3"/>
+          <p:cNvSpPr/>
+          <p:nvPr/>
+        </p:nvSpPr>
+        <p:spPr>
+          <a:xfrm>
+            <a:off x="10863072" y="237744"/>
+            <a:ext cx="841248" cy="841248"/>
+          </a:xfrm>
+          <a:prstGeom prst="ellipse">
+            <a:avLst/>
+          </a:prstGeom>
+          <a:solidFill>
+            <a:srgbClr val="1B2A4A"/>
+          </a:solidFill>
+          <a:ln/>
+        </p:spPr>
+      </p:sp>
+      <p:pic>
+        <p:nvPicPr>
+          <p:cNvPr id="6" name="Image 0" descr="preencoded.png">    </p:cNvPr>
+          <p:cNvPicPr>
+            <a:picLocks noChangeAspect="1"/>
+          </p:cNvPicPr>
+          <p:nvPr/>
+        </p:nvPicPr>
+        <p:blipFill>
+          <a:blip r:embed="rId1"/>
+          <a:stretch>
+            <a:fillRect/>
+          </a:stretch>
+        </p:blipFill>
+        <p:spPr>
+          <a:xfrm>
+            <a:off x="11105388" y="480060"/>
+            <a:ext cx="356616" cy="356616"/>
+          </a:xfrm>
+          <a:prstGeom prst="rect">
+            <a:avLst/>
+          </a:prstGeom>
+        </p:spPr>
+      </p:pic>
+      <p:sp>
+        <p:nvSpPr>
+          <p:cNvPr id="7" name="Shape 4"/>
+          <p:cNvSpPr/>
+          <p:nvPr/>
+        </p:nvSpPr>
+        <p:spPr>
+          <a:xfrm>
+            <a:off x="457200" y="1481328"/>
+            <a:ext cx="2682164" cy="914400"/>
+          </a:xfrm>
+          <a:prstGeom prst="roundRect">
+            <a:avLst>
+              <a:gd name="adj" fmla="val 8000"/>
+            </a:avLst>
+          </a:prstGeom>
+          <a:solidFill>
+            <a:srgbClr val="EEF2F7"/>
+          </a:solidFill>
+          <a:ln/>
+          <a:effectLst>
+            <a:outerShdw sx="100000" sy="100000" kx="0" ky="0" algn="bl" rotWithShape="0" blurRad="63500" dist="19050" dir="5400000">
+              <a:srgbClr val="B7C2D0">
+                <a:alpha val="35000"/>
+              </a:srgbClr>
+            </a:outerShdw>
+          </a:effectLst>
+        </p:spPr>
+      </p:sp>
+      <p:sp>
+        <p:nvSpPr>
+          <p:cNvPr id="8" name="Text 5"/>
+          <p:cNvSpPr/>
+          <p:nvPr/>
+        </p:nvSpPr>
+        <p:spPr>
+          <a:xfrm>
+            <a:off x="457200" y="1572768"/>
+            <a:ext cx="2682164" cy="402336"/>
+          </a:xfrm>
+          <a:prstGeom prst="rect">
+            <a:avLst/>
+          </a:prstGeom>
+          <a:noFill/>
+          <a:ln/>
+        </p:spPr>
+        <p:txBody>
+          <a:bodyPr wrap="square" lIns="0" tIns="0" rIns="0" bIns="0" rtlCol="0" anchor="ctr"/>
+          <a:lstStyle/>
+          <a:p>
+            <a:pPr algn="ctr" indent="0" marL="0">
+              <a:buNone/>
+            </a:pPr>
+            <a:r>
+              <a:rPr lang="en-US" sz="2100" b="1" dirty="0">
+                <a:solidFill>
+                  <a:srgbClr val="E2A33D"/>
+                </a:solidFill>
+                <a:latin typeface="Calibri" pitchFamily="34" charset="0"/>
+                <a:ea typeface="Calibri" pitchFamily="34" charset="-122"/>
+                <a:cs typeface="Calibri" pitchFamily="34" charset="-120"/>
+              </a:rPr>
+              <a:t>~80%</a:t>
+            </a:r>
+            <a:endParaRPr lang="en-US" sz="2100" dirty="0"/>
+          </a:p>
+        </p:txBody>
+      </p:sp>
+      <p:sp>
+        <p:nvSpPr>
+          <p:cNvPr id="9" name="Text 6"/>
+          <p:cNvSpPr/>
+          <p:nvPr/>
+        </p:nvSpPr>
+        <p:spPr>
+          <a:xfrm>
+            <a:off x="512064" y="1984248"/>
+            <a:ext cx="2572436" cy="384048"/>
+          </a:xfrm>
+          <a:prstGeom prst="rect">
+            <a:avLst/>
+          </a:prstGeom>
+          <a:noFill/>
+          <a:ln/>
+        </p:spPr>
+        <p:txBody>
+          <a:bodyPr wrap="square" lIns="0" tIns="0" rIns="0" bIns="0" rtlCol="0" anchor="ctr"/>
+          <a:lstStyle/>
+          <a:p>
+            <a:pPr algn="ctr" indent="0" marL="0">
+              <a:buNone/>
+            </a:pPr>
+            <a:r>
+              <a:rPr lang="en-US" sz="900" dirty="0">
+                <a:solidFill>
+                  <a:srgbClr val="263447"/>
+                </a:solidFill>
+                <a:latin typeface="Calibri" pitchFamily="34" charset="0"/>
+                <a:ea typeface="Calibri" pitchFamily="34" charset="-122"/>
+                <a:cs typeface="Calibri" pitchFamily="34" charset="-120"/>
+              </a:rPr>
+              <a:t>Energy Share of Exports (2025, IMF)</a:t>
+            </a:r>
+            <a:endParaRPr lang="en-US" sz="900" dirty="0"/>
+          </a:p>
+        </p:txBody>
+      </p:sp>
+      <p:sp>
+        <p:nvSpPr>
+          <p:cNvPr id="10" name="Shape 7"/>
+          <p:cNvSpPr/>
+          <p:nvPr/>
+        </p:nvSpPr>
+        <p:spPr>
+          <a:xfrm>
+            <a:off x="3322244" y="1481328"/>
+            <a:ext cx="2682164" cy="914400"/>
+          </a:xfrm>
+          <a:prstGeom prst="roundRect">
+            <a:avLst>
+              <a:gd name="adj" fmla="val 8000"/>
+            </a:avLst>
+          </a:prstGeom>
+          <a:solidFill>
+            <a:srgbClr val="EEF2F7"/>
+          </a:solidFill>
+          <a:ln/>
+          <a:effectLst>
+            <a:outerShdw sx="100000" sy="100000" kx="0" ky="0" algn="bl" rotWithShape="0" blurRad="63500" dist="19050" dir="5400000">
+              <a:srgbClr val="B7C2D0">
+                <a:alpha val="35000"/>
+              </a:srgbClr>
+            </a:outerShdw>
+          </a:effectLst>
+        </p:spPr>
+      </p:sp>
+      <p:sp>
+        <p:nvSpPr>
+          <p:cNvPr id="11" name="Text 8"/>
+          <p:cNvSpPr/>
+          <p:nvPr/>
+        </p:nvSpPr>
+        <p:spPr>
+          <a:xfrm>
+            <a:off x="3322244" y="1572768"/>
+            <a:ext cx="2682164" cy="402336"/>
+          </a:xfrm>
+          <a:prstGeom prst="rect">
+            <a:avLst/>
+          </a:prstGeom>
+          <a:noFill/>
+          <a:ln/>
+        </p:spPr>
+        <p:txBody>
+          <a:bodyPr wrap="square" lIns="0" tIns="0" rIns="0" bIns="0" rtlCol="0" anchor="ctr"/>
+          <a:lstStyle/>
+          <a:p>
+            <a:pPr algn="ctr" indent="0" marL="0">
+              <a:buNone/>
+            </a:pPr>
+            <a:r>
+              <a:rPr lang="en-US" sz="2100" b="1" dirty="0">
+                <a:solidFill>
+                  <a:srgbClr val="E2A33D"/>
+                </a:solidFill>
+                <a:latin typeface="Calibri" pitchFamily="34" charset="0"/>
+                <a:ea typeface="Calibri" pitchFamily="34" charset="-122"/>
+                <a:cs typeface="Calibri" pitchFamily="34" charset="-120"/>
+              </a:rPr>
+              <a:t>4.6%</a:t>
+            </a:r>
+            <a:endParaRPr lang="en-US" sz="2100" dirty="0"/>
+          </a:p>
+        </p:txBody>
+      </p:sp>
+      <p:sp>
+        <p:nvSpPr>
+          <p:cNvPr id="12" name="Text 9"/>
+          <p:cNvSpPr/>
+          <p:nvPr/>
+        </p:nvSpPr>
+        <p:spPr>
+          <a:xfrm>
+            <a:off x="3377108" y="1984248"/>
+            <a:ext cx="2572436" cy="384048"/>
+          </a:xfrm>
+          <a:prstGeom prst="rect">
+            <a:avLst/>
+          </a:prstGeom>
+          <a:noFill/>
+          <a:ln/>
+        </p:spPr>
+        <p:txBody>
+          <a:bodyPr wrap="square" lIns="0" tIns="0" rIns="0" bIns="0" rtlCol="0" anchor="ctr"/>
+          <a:lstStyle/>
+          <a:p>
+            <a:pPr algn="ctr" indent="0" marL="0">
+              <a:buNone/>
+            </a:pPr>
+            <a:r>
+              <a:rPr lang="en-US" sz="900" dirty="0">
+                <a:solidFill>
+                  <a:srgbClr val="263447"/>
+                </a:solidFill>
+                <a:latin typeface="Calibri" pitchFamily="34" charset="0"/>
+                <a:ea typeface="Calibri" pitchFamily="34" charset="-122"/>
+                <a:cs typeface="Calibri" pitchFamily="34" charset="-120"/>
+              </a:rPr>
+              <a:t>2026 Fiscal Deficit — down from 5.5%</a:t>
+            </a:r>
+            <a:endParaRPr lang="en-US" sz="900" dirty="0"/>
+          </a:p>
+        </p:txBody>
+      </p:sp>
+      <p:sp>
+        <p:nvSpPr>
+          <p:cNvPr id="13" name="Shape 10"/>
+          <p:cNvSpPr/>
+          <p:nvPr/>
+        </p:nvSpPr>
+        <p:spPr>
+          <a:xfrm>
+            <a:off x="6187288" y="1481328"/>
+            <a:ext cx="2682164" cy="914400"/>
+          </a:xfrm>
+          <a:prstGeom prst="roundRect">
+            <a:avLst>
+              <a:gd name="adj" fmla="val 8000"/>
+            </a:avLst>
+          </a:prstGeom>
+          <a:solidFill>
+            <a:srgbClr val="EEF2F7"/>
+          </a:solidFill>
+          <a:ln/>
+          <a:effectLst>
+            <a:outerShdw sx="100000" sy="100000" kx="0" ky="0" algn="bl" rotWithShape="0" blurRad="63500" dist="19050" dir="5400000">
+              <a:srgbClr val="B7C2D0">
+                <a:alpha val="35000"/>
+              </a:srgbClr>
+            </a:outerShdw>
+          </a:effectLst>
+        </p:spPr>
+      </p:sp>
+      <p:sp>
+        <p:nvSpPr>
+          <p:cNvPr id="14" name="Text 11"/>
+          <p:cNvSpPr/>
+          <p:nvPr/>
+        </p:nvSpPr>
+        <p:spPr>
+          <a:xfrm>
+            <a:off x="6187288" y="1572768"/>
+            <a:ext cx="2682164" cy="402336"/>
+          </a:xfrm>
+          <a:prstGeom prst="rect">
+            <a:avLst/>
+          </a:prstGeom>
+          <a:noFill/>
+          <a:ln/>
+        </p:spPr>
+        <p:txBody>
+          <a:bodyPr wrap="square" lIns="0" tIns="0" rIns="0" bIns="0" rtlCol="0" anchor="ctr"/>
+          <a:lstStyle/>
+          <a:p>
+            <a:pPr algn="ctr" indent="0" marL="0">
+              <a:buNone/>
+            </a:pPr>
+            <a:r>
+              <a:rPr lang="en-US" sz="2100" b="1" dirty="0">
+                <a:solidFill>
+                  <a:srgbClr val="E2A33D"/>
+                </a:solidFill>
+                <a:latin typeface="Calibri" pitchFamily="34" charset="0"/>
+                <a:ea typeface="Calibri" pitchFamily="34" charset="-122"/>
+                <a:cs typeface="Calibri" pitchFamily="34" charset="-120"/>
+              </a:rPr>
+              <a:t>24%</a:t>
+            </a:r>
+            <a:endParaRPr lang="en-US" sz="2100" dirty="0"/>
+          </a:p>
+        </p:txBody>
+      </p:sp>
+      <p:sp>
+        <p:nvSpPr>
+          <p:cNvPr id="15" name="Text 12"/>
+          <p:cNvSpPr/>
+          <p:nvPr/>
+        </p:nvSpPr>
+        <p:spPr>
+          <a:xfrm>
+            <a:off x="6242152" y="1984248"/>
+            <a:ext cx="2572436" cy="384048"/>
+          </a:xfrm>
+          <a:prstGeom prst="rect">
+            <a:avLst/>
+          </a:prstGeom>
+          <a:noFill/>
+          <a:ln/>
+        </p:spPr>
+        <p:txBody>
+          <a:bodyPr wrap="square" lIns="0" tIns="0" rIns="0" bIns="0" rtlCol="0" anchor="ctr"/>
+          <a:lstStyle/>
+          <a:p>
+            <a:pPr algn="ctr" indent="0" marL="0">
+              <a:buNone/>
+            </a:pPr>
+            <a:r>
+              <a:rPr lang="en-US" sz="900" dirty="0">
+                <a:solidFill>
+                  <a:srgbClr val="263447"/>
+                </a:solidFill>
+                <a:latin typeface="Calibri" pitchFamily="34" charset="0"/>
+                <a:ea typeface="Calibri" pitchFamily="34" charset="-122"/>
+                <a:cs typeface="Calibri" pitchFamily="34" charset="-120"/>
+              </a:rPr>
+              <a:t>HSF Assets, % of GDP (end-FY2025)</a:t>
+            </a:r>
+            <a:endParaRPr lang="en-US" sz="900" dirty="0"/>
+          </a:p>
+        </p:txBody>
+      </p:sp>
+      <p:sp>
+        <p:nvSpPr>
+          <p:cNvPr id="16" name="Shape 13"/>
+          <p:cNvSpPr/>
+          <p:nvPr/>
+        </p:nvSpPr>
+        <p:spPr>
+          <a:xfrm>
+            <a:off x="9052331" y="1481328"/>
+            <a:ext cx="2682164" cy="914400"/>
+          </a:xfrm>
+          <a:prstGeom prst="roundRect">
+            <a:avLst>
+              <a:gd name="adj" fmla="val 8000"/>
+            </a:avLst>
+          </a:prstGeom>
+          <a:solidFill>
+            <a:srgbClr val="EEF2F7"/>
+          </a:solidFill>
+          <a:ln/>
+          <a:effectLst>
+            <a:outerShdw sx="100000" sy="100000" kx="0" ky="0" algn="bl" rotWithShape="0" blurRad="63500" dist="19050" dir="5400000">
+              <a:srgbClr val="B7C2D0">
+                <a:alpha val="35000"/>
+              </a:srgbClr>
+            </a:outerShdw>
+          </a:effectLst>
+        </p:spPr>
+      </p:sp>
+      <p:sp>
+        <p:nvSpPr>
+          <p:cNvPr id="17" name="Text 14"/>
+          <p:cNvSpPr/>
+          <p:nvPr/>
+        </p:nvSpPr>
+        <p:spPr>
+          <a:xfrm>
+            <a:off x="9052331" y="1572768"/>
+            <a:ext cx="2682164" cy="402336"/>
+          </a:xfrm>
+          <a:prstGeom prst="rect">
+            <a:avLst/>
+          </a:prstGeom>
+          <a:noFill/>
+          <a:ln/>
+        </p:spPr>
+        <p:txBody>
+          <a:bodyPr wrap="square" lIns="0" tIns="0" rIns="0" bIns="0" rtlCol="0" anchor="ctr"/>
+          <a:lstStyle/>
+          <a:p>
+            <a:pPr algn="ctr" indent="0" marL="0">
+              <a:buNone/>
+            </a:pPr>
+            <a:r>
+              <a:rPr lang="en-US" sz="2100" b="1" dirty="0">
+                <a:solidFill>
+                  <a:srgbClr val="E2A33D"/>
+                </a:solidFill>
+                <a:latin typeface="Calibri" pitchFamily="34" charset="0"/>
+                <a:ea typeface="Calibri" pitchFamily="34" charset="-122"/>
+                <a:cs typeface="Calibri" pitchFamily="34" charset="-120"/>
+              </a:rPr>
+              <a:t>68%</a:t>
+            </a:r>
+            <a:endParaRPr lang="en-US" sz="2100" dirty="0"/>
+          </a:p>
+        </p:txBody>
+      </p:sp>
+      <p:sp>
+        <p:nvSpPr>
+          <p:cNvPr id="18" name="Text 15"/>
+          <p:cNvSpPr/>
+          <p:nvPr/>
+        </p:nvSpPr>
+        <p:spPr>
+          <a:xfrm>
+            <a:off x="9107195" y="1984248"/>
+            <a:ext cx="2572436" cy="384048"/>
+          </a:xfrm>
+          <a:prstGeom prst="rect">
+            <a:avLst/>
+          </a:prstGeom>
+          <a:noFill/>
+          <a:ln/>
+        </p:spPr>
+        <p:txBody>
+          <a:bodyPr wrap="square" lIns="0" tIns="0" rIns="0" bIns="0" rtlCol="0" anchor="ctr"/>
+          <a:lstStyle/>
+          <a:p>
+            <a:pPr algn="ctr" indent="0" marL="0">
+              <a:buNone/>
+            </a:pPr>
+            <a:r>
+              <a:rPr lang="en-US" sz="900" dirty="0">
+                <a:solidFill>
+                  <a:srgbClr val="263447"/>
+                </a:solidFill>
+                <a:latin typeface="Calibri" pitchFamily="34" charset="0"/>
+                <a:ea typeface="Calibri" pitchFamily="34" charset="-122"/>
+                <a:cs typeface="Calibri" pitchFamily="34" charset="-120"/>
+              </a:rPr>
+              <a:t>Public Debt, % of GDP (end-2025)</a:t>
+            </a:r>
+            <a:endParaRPr lang="en-US" sz="900" dirty="0"/>
+          </a:p>
+        </p:txBody>
+      </p:sp>
+      <p:sp>
+        <p:nvSpPr>
+          <p:cNvPr id="19" name="Shape 16"/>
+          <p:cNvSpPr/>
+          <p:nvPr/>
+        </p:nvSpPr>
+        <p:spPr>
+          <a:xfrm>
+            <a:off x="457200" y="2395728"/>
+            <a:ext cx="365760" cy="365760"/>
+          </a:xfrm>
+          <a:prstGeom prst="ellipse">
+            <a:avLst/>
+          </a:prstGeom>
+          <a:solidFill>
+            <a:srgbClr val="1B2A4A"/>
+          </a:solidFill>
+          <a:ln/>
+        </p:spPr>
+      </p:sp>
+      <p:pic>
+        <p:nvPicPr>
+          <p:cNvPr id="20" name="Image 1" descr="preencoded.png">    </p:cNvPr>
+          <p:cNvPicPr>
+            <a:picLocks noChangeAspect="1"/>
+          </p:cNvPicPr>
+          <p:nvPr/>
+        </p:nvPicPr>
+        <p:blipFill>
+          <a:blip r:embed="rId2"/>
+          <a:stretch>
+            <a:fillRect/>
+          </a:stretch>
+        </p:blipFill>
+        <p:spPr>
+          <a:xfrm>
+            <a:off x="534924" y="2473452"/>
+            <a:ext cx="210312" cy="210312"/>
+          </a:xfrm>
+          <a:prstGeom prst="rect">
+            <a:avLst/>
+          </a:prstGeom>
+        </p:spPr>
+      </p:pic>
+      <p:sp>
+        <p:nvSpPr>
+          <p:cNvPr id="21" name="Text 17"/>
+          <p:cNvSpPr/>
+          <p:nvPr/>
+        </p:nvSpPr>
+        <p:spPr>
+          <a:xfrm>
+            <a:off x="932688" y="2377440"/>
+            <a:ext cx="5003140" cy="402336"/>
+          </a:xfrm>
+          <a:prstGeom prst="rect">
+            <a:avLst/>
+          </a:prstGeom>
+          <a:noFill/>
+          <a:ln/>
+        </p:spPr>
+        <p:txBody>
+          <a:bodyPr wrap="square" lIns="0" tIns="0" rIns="0" bIns="0" rtlCol="0" anchor="ctr"/>
+          <a:lstStyle/>
+          <a:p>
+            <a:pPr indent="0" marL="0">
+              <a:buNone/>
+            </a:pPr>
+            <a:r>
+              <a:rPr lang="en-US" sz="1450" b="1" dirty="0">
+                <a:solidFill>
+                  <a:srgbClr val="1B2A4A"/>
+                </a:solidFill>
+                <a:latin typeface="Calibri" pitchFamily="34" charset="0"/>
+                <a:ea typeface="Calibri" pitchFamily="34" charset="-122"/>
+                <a:cs typeface="Calibri" pitchFamily="34" charset="-120"/>
+              </a:rPr>
+              <a:t>Energy Concentration &amp; FX Exposure</a:t>
+            </a:r>
+            <a:endParaRPr lang="en-US" sz="1450" dirty="0"/>
+          </a:p>
+        </p:txBody>
+      </p:sp>
+      <p:sp>
+        <p:nvSpPr>
+          <p:cNvPr id="22" name="Text 18"/>
+          <p:cNvSpPr/>
+          <p:nvPr/>
+        </p:nvSpPr>
+        <p:spPr>
+          <a:xfrm>
+            <a:off x="457200" y="2871216"/>
+            <a:ext cx="5478628" cy="1417320"/>
+          </a:xfrm>
+          <a:prstGeom prst="rect">
+            <a:avLst/>
+          </a:prstGeom>
+          <a:noFill/>
+          <a:ln/>
+        </p:spPr>
+        <p:txBody>
+          <a:bodyPr wrap="square" lIns="0" tIns="0" rIns="0" bIns="0" rtlCol="0" anchor="t"/>
+          <a:lstStyle/>
+          <a:p>
+            <a:pPr marL="152400" indent="-152400">
+              <a:lnSpc>
+                <a:spcPct val="102000"/>
+              </a:lnSpc>
+              <a:spcAft>
+                <a:spcPts val="800"/>
+              </a:spcAft>
+              <a:buSzPct val="100000"/>
+              <a:buChar char="●"/>
+            </a:pPr>
+            <a:r>
+              <a:rPr lang="en-US" sz="1050" dirty="0">
+                <a:solidFill>
+                  <a:srgbClr val="263447"/>
+                </a:solidFill>
+                <a:latin typeface="Calibri" pitchFamily="34" charset="0"/>
+                <a:ea typeface="Calibri" pitchFamily="34" charset="-122"/>
+                <a:cs typeface="Calibri" pitchFamily="34" charset="-120"/>
+              </a:rPr>
+              <a:t>Energy: ~20% of GDP, ~80% of exports, ~35% of govt. revenue (2025, IMF) — FX and fiscal revenue both hinge on a shrinking resource base</a:t>
+            </a:r>
+            <a:endParaRPr lang="en-US" sz="1050" dirty="0"/>
+          </a:p>
+          <a:p>
+            <a:pPr marL="152400" indent="-152400">
+              <a:lnSpc>
+                <a:spcPct val="102000"/>
+              </a:lnSpc>
+              <a:spcAft>
+                <a:spcPts val="800"/>
+              </a:spcAft>
+              <a:buSzPct val="100000"/>
+              <a:buChar char="●"/>
+            </a:pPr>
+            <a:r>
+              <a:rPr lang="en-US" sz="1050" dirty="0">
+                <a:solidFill>
+                  <a:srgbClr val="263447"/>
+                </a:solidFill>
+                <a:latin typeface="Calibri" pitchFamily="34" charset="0"/>
+                <a:ea typeface="Calibri" pitchFamily="34" charset="-122"/>
+                <a:cs typeface="Calibri" pitchFamily="34" charset="-120"/>
+              </a:rPr>
+              <a:t>Gas output already ~40% below its 2010 peak (IMF); Wood Mackenzie’s field-level outlook projects continued structural decline absent new project sanctions</a:t>
+            </a:r>
+            <a:endParaRPr lang="en-US" sz="1050" dirty="0"/>
+          </a:p>
+          <a:p>
+            <a:pPr marL="152400" indent="-152400">
+              <a:lnSpc>
+                <a:spcPct val="102000"/>
+              </a:lnSpc>
+              <a:spcAft>
+                <a:spcPts val="800"/>
+              </a:spcAft>
+              <a:buSzPct val="100000"/>
+              <a:buChar char="●"/>
+            </a:pPr>
+            <a:r>
+              <a:rPr lang="en-US" sz="1050" dirty="0">
+                <a:solidFill>
+                  <a:srgbClr val="263447"/>
+                </a:solidFill>
+                <a:latin typeface="Calibri" pitchFamily="34" charset="0"/>
+                <a:ea typeface="Calibri" pitchFamily="34" charset="-122"/>
+                <a:cs typeface="Calibri" pitchFamily="34" charset="-120"/>
+              </a:rPr>
+              <a:t>New supply (Cypre online Apr-2025; Manatee targeted end-2027) offers a near-term offset, not a reversal of the multi-decade trend</a:t>
+            </a:r>
+            <a:endParaRPr lang="en-US" sz="1050" dirty="0"/>
+          </a:p>
+        </p:txBody>
+      </p:sp>
+      <p:sp>
+        <p:nvSpPr>
+          <p:cNvPr id="23" name="Shape 19"/>
+          <p:cNvSpPr/>
+          <p:nvPr/>
+        </p:nvSpPr>
+        <p:spPr>
+          <a:xfrm>
+            <a:off x="457200" y="4352544"/>
+            <a:ext cx="5478628" cy="2002536"/>
+          </a:xfrm>
+          <a:prstGeom prst="roundRect">
+            <a:avLst>
+              <a:gd name="adj" fmla="val 2740"/>
+            </a:avLst>
+          </a:prstGeom>
+          <a:solidFill>
+            <a:srgbClr val="F5F6F8"/>
+          </a:solidFill>
+          <a:ln w="12700">
+            <a:solidFill>
+              <a:srgbClr val="C7D0DC"/>
+            </a:solidFill>
+            <a:prstDash val="dash"/>
+          </a:ln>
+        </p:spPr>
+      </p:sp>
+      <p:sp>
+        <p:nvSpPr>
+          <p:cNvPr id="24" name="Text 20"/>
+          <p:cNvSpPr/>
+          <p:nvPr/>
+        </p:nvSpPr>
+        <p:spPr>
+          <a:xfrm>
+            <a:off x="777240" y="4581144"/>
+            <a:ext cx="4838548" cy="1545336"/>
+          </a:xfrm>
+          <a:prstGeom prst="rect">
+            <a:avLst/>
+          </a:prstGeom>
+          <a:noFill/>
+          <a:ln/>
+        </p:spPr>
+        <p:txBody>
+          <a:bodyPr wrap="square" lIns="0" tIns="0" rIns="0" bIns="0" rtlCol="0" anchor="ctr"/>
+          <a:lstStyle/>
+          <a:p>
+            <a:pPr algn="ctr" indent="0" marL="0">
+              <a:lnSpc>
+                <a:spcPct val="115000"/>
+              </a:lnSpc>
+              <a:buNone/>
+            </a:pPr>
+            <a:r>
+              <a:rPr lang="en-US" sz="1150" b="1" dirty="0">
+                <a:solidFill>
+                  <a:srgbClr val="6B7787"/>
+                </a:solidFill>
+              </a:rPr>
+              <a:t>ENERGY INSTITUTE + WOOD MACKENZIE</a:t>
+            </a:r>
+            <a:endParaRPr lang="en-US" sz="1150" dirty="0"/>
+          </a:p>
+          <a:p>
+            <a:pPr algn="ctr" indent="0" marL="0">
+              <a:lnSpc>
+                <a:spcPct val="115000"/>
+              </a:lnSpc>
+              <a:buNone/>
+            </a:pPr>
+            <a:r>
+              <a:rPr lang="en-US" sz="1000" i="1" dirty="0">
+                <a:solidFill>
+                  <a:srgbClr val="6B7787"/>
+                </a:solidFill>
+              </a:rPr>
+              <a:t>Gas production vs. domestic consumption &amp; LNG exports, 2000–2048 (historical actuals + WoodMac forecast)</a:t>
+            </a:r>
+            <a:endParaRPr lang="en-US" sz="1150" dirty="0"/>
+          </a:p>
+          <a:p>
+            <a:pPr algn="ctr" indent="0" marL="0">
+              <a:lnSpc>
+                <a:spcPct val="115000"/>
+              </a:lnSpc>
+              <a:buNone/>
+            </a:pPr>
+            <a:r>
+              <a:rPr lang="en-US" sz="1000" i="1" dirty="0">
+                <a:solidFill>
+                  <a:srgbClr val="9AA7B8"/>
+                </a:solidFill>
+              </a:rPr>
+              <a:t>[ Paste chart here ]</a:t>
+            </a:r>
+            <a:endParaRPr lang="en-US" sz="1150" dirty="0"/>
+          </a:p>
+        </p:txBody>
+      </p:sp>
+      <p:sp>
+        <p:nvSpPr>
+          <p:cNvPr id="25" name="Shape 21"/>
+          <p:cNvSpPr/>
+          <p:nvPr/>
+        </p:nvSpPr>
+        <p:spPr>
+          <a:xfrm>
+            <a:off x="6255868" y="2395728"/>
+            <a:ext cx="310896" cy="310896"/>
+          </a:xfrm>
+          <a:prstGeom prst="ellipse">
+            <a:avLst/>
+          </a:prstGeom>
+          <a:solidFill>
+            <a:srgbClr val="1B2A4A"/>
+          </a:solidFill>
+          <a:ln/>
+        </p:spPr>
+      </p:sp>
+      <p:pic>
+        <p:nvPicPr>
+          <p:cNvPr id="26" name="Image 2" descr="preencoded.png">    </p:cNvPr>
+          <p:cNvPicPr>
+            <a:picLocks noChangeAspect="1"/>
+          </p:cNvPicPr>
+          <p:nvPr/>
+        </p:nvPicPr>
+        <p:blipFill>
+          <a:blip r:embed="rId3"/>
+          <a:stretch>
+            <a:fillRect/>
+          </a:stretch>
+        </p:blipFill>
+        <p:spPr>
+          <a:xfrm>
+            <a:off x="6319876" y="2459736"/>
+            <a:ext cx="182880" cy="182880"/>
+          </a:xfrm>
+          <a:prstGeom prst="rect">
+            <a:avLst/>
+          </a:prstGeom>
+        </p:spPr>
+      </p:pic>
+      <p:sp>
+        <p:nvSpPr>
+          <p:cNvPr id="27" name="Text 22"/>
+          <p:cNvSpPr/>
+          <p:nvPr/>
+        </p:nvSpPr>
+        <p:spPr>
+          <a:xfrm>
+            <a:off x="6658204" y="2377440"/>
+            <a:ext cx="5076292" cy="347472"/>
+          </a:xfrm>
+          <a:prstGeom prst="rect">
+            <a:avLst/>
+          </a:prstGeom>
+          <a:noFill/>
+          <a:ln/>
+        </p:spPr>
+        <p:txBody>
+          <a:bodyPr wrap="square" lIns="0" tIns="0" rIns="0" bIns="0" rtlCol="0" anchor="ctr"/>
+          <a:lstStyle/>
+          <a:p>
+            <a:pPr indent="0" marL="0">
+              <a:buNone/>
+            </a:pPr>
+            <a:r>
+              <a:rPr lang="en-US" sz="1300" b="1" dirty="0">
+                <a:solidFill>
+                  <a:srgbClr val="1B2A4A"/>
+                </a:solidFill>
+                <a:latin typeface="Calibri" pitchFamily="34" charset="0"/>
+                <a:ea typeface="Calibri" pitchFamily="34" charset="-122"/>
+                <a:cs typeface="Calibri" pitchFamily="34" charset="-120"/>
+              </a:rPr>
+              <a:t>Fiscal Deficit: Narrowing, Not Yet Closed</a:t>
+            </a:r>
+            <a:endParaRPr lang="en-US" sz="1300" dirty="0"/>
+          </a:p>
+        </p:txBody>
+      </p:sp>
+      <p:graphicFrame>
+        <p:nvGraphicFramePr>
+          <p:cNvPr id="28" name="Chart 0" descr=""/>
+          <p:cNvGraphicFramePr/>
+          <p:nvPr/>
+        </p:nvGraphicFramePr>
+        <p:xfrm>
+          <a:off x="6255868" y="2743200"/>
+          <a:ext cx="5478628" cy="1298448"/>
+        </p:xfrm>
+        <a:graphic xmlns:a="http://schemas.openxmlformats.org/drawingml/2006/main">
+          <a:graphicData uri="http://schemas.openxmlformats.org/drawingml/2006/chart">
+            <c:chart xmlns:c="http://schemas.openxmlformats.org/drawingml/2006/chart" r:id="rId4"/>
+          </a:graphicData>
+        </a:graphic>
+      </p:graphicFrame>
+      <p:sp>
+        <p:nvSpPr>
+          <p:cNvPr id="29" name="Text 23"/>
+          <p:cNvSpPr/>
+          <p:nvPr/>
+        </p:nvSpPr>
+        <p:spPr>
+          <a:xfrm>
+            <a:off x="6255868" y="4059936"/>
+            <a:ext cx="5478628" cy="224028"/>
+          </a:xfrm>
+          <a:prstGeom prst="rect">
+            <a:avLst/>
+          </a:prstGeom>
+          <a:noFill/>
+          <a:ln/>
+        </p:spPr>
+        <p:txBody>
+          <a:bodyPr wrap="square" lIns="0" tIns="0" rIns="0" bIns="0" rtlCol="0" anchor="t"/>
+          <a:lstStyle/>
+          <a:p>
+            <a:pPr indent="0" marL="0">
+              <a:buNone/>
+            </a:pPr>
+            <a:r>
+              <a:rPr lang="en-US" sz="850" i="1" dirty="0">
+                <a:solidFill>
+                  <a:srgbClr val="6B7787"/>
+                </a:solidFill>
+                <a:latin typeface="Calibri" pitchFamily="34" charset="0"/>
+                <a:ea typeface="Calibri" pitchFamily="34" charset="-122"/>
+                <a:cs typeface="Calibri" pitchFamily="34" charset="-120"/>
+              </a:rPr>
+              <a:t>Debt stock still elevated at ~68% of GDP (end-2025) vs. ~27% in 2005 (avg. ~43% over 1990–2008) — the flow is improving before the stock stabilizes</a:t>
+            </a:r>
+            <a:endParaRPr lang="en-US" sz="850" dirty="0"/>
+          </a:p>
+        </p:txBody>
+      </p:sp>
+      <p:sp>
+        <p:nvSpPr>
+          <p:cNvPr id="30" name="Shape 24"/>
+          <p:cNvSpPr/>
+          <p:nvPr/>
+        </p:nvSpPr>
+        <p:spPr>
+          <a:xfrm>
+            <a:off x="6255868" y="4466844"/>
+            <a:ext cx="310896" cy="310896"/>
+          </a:xfrm>
+          <a:prstGeom prst="ellipse">
+            <a:avLst/>
+          </a:prstGeom>
+          <a:solidFill>
+            <a:srgbClr val="1B2A4A"/>
+          </a:solidFill>
+          <a:ln/>
+        </p:spPr>
+      </p:sp>
+      <p:pic>
+        <p:nvPicPr>
+          <p:cNvPr id="31" name="Image 3" descr="preencoded.png">    </p:cNvPr>
+          <p:cNvPicPr>
+            <a:picLocks noChangeAspect="1"/>
+          </p:cNvPicPr>
+          <p:nvPr/>
+        </p:nvPicPr>
+        <p:blipFill>
+          <a:blip r:embed="rId5"/>
+          <a:stretch>
+            <a:fillRect/>
+          </a:stretch>
+        </p:blipFill>
+        <p:spPr>
+          <a:xfrm>
+            <a:off x="6319876" y="4530852"/>
+            <a:ext cx="182880" cy="182880"/>
+          </a:xfrm>
+          <a:prstGeom prst="rect">
+            <a:avLst/>
+          </a:prstGeom>
+        </p:spPr>
+      </p:pic>
+      <p:sp>
+        <p:nvSpPr>
+          <p:cNvPr id="32" name="Text 25"/>
+          <p:cNvSpPr/>
+          <p:nvPr/>
+        </p:nvSpPr>
+        <p:spPr>
+          <a:xfrm>
+            <a:off x="6658204" y="4448556"/>
+            <a:ext cx="5076292" cy="347472"/>
+          </a:xfrm>
+          <a:prstGeom prst="rect">
+            <a:avLst/>
+          </a:prstGeom>
+          <a:noFill/>
+          <a:ln/>
+        </p:spPr>
+        <p:txBody>
+          <a:bodyPr wrap="square" lIns="0" tIns="0" rIns="0" bIns="0" rtlCol="0" anchor="ctr"/>
+          <a:lstStyle/>
+          <a:p>
+            <a:pPr indent="0" marL="0">
+              <a:buNone/>
+            </a:pPr>
+            <a:r>
+              <a:rPr lang="en-US" sz="1300" b="1" dirty="0">
+                <a:solidFill>
+                  <a:srgbClr val="1B2A4A"/>
+                </a:solidFill>
+                <a:latin typeface="Calibri" pitchFamily="34" charset="0"/>
+                <a:ea typeface="Calibri" pitchFamily="34" charset="-122"/>
+                <a:cs typeface="Calibri" pitchFamily="34" charset="-120"/>
+              </a:rPr>
+              <a:t>Heritage &amp; Stabilisation Fund — Built for This</a:t>
+            </a:r>
+            <a:endParaRPr lang="en-US" sz="1300" dirty="0"/>
+          </a:p>
+        </p:txBody>
+      </p:sp>
+      <p:graphicFrame>
+        <p:nvGraphicFramePr>
+          <p:cNvPr id="33" name="Chart 1" descr=""/>
+          <p:cNvGraphicFramePr/>
+          <p:nvPr/>
+        </p:nvGraphicFramePr>
+        <p:xfrm>
+          <a:off x="6255868" y="4814316"/>
+          <a:ext cx="5478628" cy="1298448"/>
+        </p:xfrm>
+        <a:graphic xmlns:a="http://schemas.openxmlformats.org/drawingml/2006/main">
+          <a:graphicData uri="http://schemas.openxmlformats.org/drawingml/2006/chart">
+            <c:chart xmlns:c="http://schemas.openxmlformats.org/drawingml/2006/chart" r:id="rId6"/>
+          </a:graphicData>
+        </a:graphic>
+      </p:graphicFrame>
+      <p:sp>
+        <p:nvSpPr>
+          <p:cNvPr id="34" name="Text 26"/>
+          <p:cNvSpPr/>
+          <p:nvPr/>
+        </p:nvSpPr>
+        <p:spPr>
+          <a:xfrm>
+            <a:off x="6255868" y="6131052"/>
+            <a:ext cx="5478628" cy="224028"/>
+          </a:xfrm>
+          <a:prstGeom prst="rect">
+            <a:avLst/>
+          </a:prstGeom>
+          <a:noFill/>
+          <a:ln/>
+        </p:spPr>
+        <p:txBody>
+          <a:bodyPr wrap="square" lIns="0" tIns="0" rIns="0" bIns="0" rtlCol="0" anchor="t"/>
+          <a:lstStyle/>
+          <a:p>
+            <a:pPr indent="0" marL="0">
+              <a:buNone/>
+            </a:pPr>
+            <a:r>
+              <a:rPr lang="en-US" sz="850" i="1" dirty="0">
+                <a:solidFill>
+                  <a:srgbClr val="6B7787"/>
+                </a:solidFill>
+                <a:latin typeface="Calibri" pitchFamily="34" charset="0"/>
+                <a:ea typeface="Calibri" pitchFamily="34" charset="-122"/>
+                <a:cs typeface="Calibri" pitchFamily="34" charset="-120"/>
+              </a:rPr>
+              <a:t>Sovereign Wealth Fund Assets, % of GDP (2024) — T&amp;T’s HSF (highlighted) holds &gt;US$6bn (~24% of GDP, end-FY2025): modest vs. Gulf/Norway peers, but purpose-built for this exposure</a:t>
+            </a:r>
+            <a:endParaRPr lang="en-US" sz="850" dirty="0"/>
+          </a:p>
+        </p:txBody>
+      </p:sp>
+      <p:sp>
+        <p:nvSpPr>
+          <p:cNvPr id="35" name="Text 27"/>
+          <p:cNvSpPr/>
+          <p:nvPr/>
+        </p:nvSpPr>
+        <p:spPr>
+          <a:xfrm>
+            <a:off x="457200" y="6473952"/>
+            <a:ext cx="11277295" cy="310896"/>
+          </a:xfrm>
+          <a:prstGeom prst="rect">
+            <a:avLst/>
+          </a:prstGeom>
+          <a:noFill/>
+          <a:ln/>
+        </p:spPr>
+        <p:txBody>
+          <a:bodyPr wrap="square" lIns="0" tIns="0" rIns="0" bIns="0" rtlCol="0" anchor="ctr"/>
+          <a:lstStyle/>
+          <a:p>
+            <a:pPr indent="0" marL="0">
+              <a:buNone/>
+            </a:pPr>
+            <a:r>
+              <a:rPr lang="en-US" sz="800" i="1" dirty="0">
+                <a:solidFill>
+                  <a:srgbClr val="6B7787"/>
+                </a:solidFill>
+                <a:latin typeface="Calibri" pitchFamily="34" charset="0"/>
+                <a:ea typeface="Calibri" pitchFamily="34" charset="-122"/>
+                <a:cs typeface="Calibri" pitchFamily="34" charset="-120"/>
+              </a:rPr>
+              <a:t>Sources: IMF Country Report No. 26/121, Selected Issues (June 2026) — Fiscal Developments and Sovereign Wealth Fund Assets 2024 (orig. Sovereign Wealth Fund Institute &amp; IMF staff calcs.); IMF 2026 Article IV Consultation; T&amp;T Ministry of Finance, Budget Statement FY2026 (Oct 2025); Wood Mackenzie production data (chart to be inserted).</a:t>
             </a:r>
             <a:endParaRPr lang="en-US" sz="800" dirty="0"/>
           </a:p>

</xml_diff>

<commit_message>
Correct fiscal deficit figures to primary-sourced Central Bank data
The prior 2025/2026f/2026-target fiscal deficit figures (5.5%/4.6%/2.2%)
were sourced via web search synthesis of the IMF Article IV, which
could not be independently verified (this session's outbound web
fetch is fully blocked, confirmed via a control test against a
neutral domain). The user supplied the Central Bank of Trinidad and
Tobago's own "Fiscal Balances and Ratios" data, which shows FY2025's
actual overall fiscal balance as -4.6% of GDP -- identical to the
figure previously mislabeled as a 2026 forecast. Replaced with the
confirmed FY2020-FY2025 actuals (-11.5, -7.8, +0.7, -1.8, -5.3, -4.6)
plus the FY2026 government budget target (-2.2%, confirmed via the
Ministry of Finance's FY2026 Budget Statement figures), dropping the
unconfirmed IMF 2026 forecast entirely. Also adds a standalone Excel
workbook of the Sovereign Wealth Fund Assets 2024 comparison chart
with full country names, per request.
</commit_message>
<xml_diff>
--- a/trinidad-tobago-macro-outlook/Trinidad_Tobago_Macro_Outlook_Power_Sector.pptx
+++ b/trinidad-tobago-macro-outlook/Trinidad_Tobago_Macro_Outlook_Power_Sector.pptx
@@ -129,7 +129,7 @@
               <c:strCache>
                 <c:ptCount val="1"/>
                 <c:pt idx="0">
-                  <c:v>Overall Fiscal Deficit</c:v>
+                  <c:v>Overall Fiscal Balance</c:v>
                 </c:pt>
               </c:strCache>
             </c:strRef>
@@ -142,13 +142,13 @@
           </c:spPr>
           <c:invertIfNegative val="0"/>
           <c:dLbls>
-            <c:numFmt formatCode="0.0" sourceLinked="0"/>
+            <c:numFmt formatCode="+0.0;-0.0;0.0" sourceLinked="0"/>
             <c:txPr>
               <a:bodyPr/>
               <a:lstStyle/>
               <a:p>
                 <a:pPr>
-                  <a:defRPr b="0" i="0" strike="noStrike" sz="1000" u="none">
+                  <a:defRPr b="0" i="0" strike="noStrike" sz="900" u="none">
                     <a:solidFill>
                       <a:srgbClr val="263447"/>
                     </a:solidFill>
@@ -193,6 +193,50 @@
             <c:bubble3D val="0"/>
             <c:spPr>
               <a:solidFill>
+                <a:srgbClr val="1B2A4A"/>
+              </a:solidFill>
+              <a:effectLst/>
+            </c:spPr>
+          </c:dPt>
+          <c:dPt>
+            <c:idx val="3"/>
+            <c:invertIfNegative val="0"/>
+            <c:bubble3D val="0"/>
+            <c:spPr>
+              <a:solidFill>
+                <a:srgbClr val="1B2A4A"/>
+              </a:solidFill>
+              <a:effectLst/>
+            </c:spPr>
+          </c:dPt>
+          <c:dPt>
+            <c:idx val="4"/>
+            <c:invertIfNegative val="0"/>
+            <c:bubble3D val="0"/>
+            <c:spPr>
+              <a:solidFill>
+                <a:srgbClr val="1B2A4A"/>
+              </a:solidFill>
+              <a:effectLst/>
+            </c:spPr>
+          </c:dPt>
+          <c:dPt>
+            <c:idx val="5"/>
+            <c:invertIfNegative val="0"/>
+            <c:bubble3D val="0"/>
+            <c:spPr>
+              <a:solidFill>
+                <a:srgbClr val="1B2A4A"/>
+              </a:solidFill>
+              <a:effectLst/>
+            </c:spPr>
+          </c:dPt>
+          <c:dPt>
+            <c:idx val="6"/>
+            <c:invertIfNegative val="0"/>
+            <c:bubble3D val="0"/>
+            <c:spPr>
+              <a:solidFill>
                 <a:srgbClr val="E2A33D"/>
               </a:solidFill>
               <a:effectLst/>
@@ -200,18 +244,30 @@
           </c:dPt>
           <c:cat>
             <c:multiLvlStrRef>
-              <c:f>Sheet1!$A$2:$A$4</c:f>
+              <c:f>Sheet1!$A$2:$A$8</c:f>
               <c:multiLvlStrCache>
-                <c:ptCount val="3"/>
+                <c:ptCount val="7"/>
                 <c:lvl>
                   <c:pt idx="0">
-                    <c:v>2025 (Actual)</c:v>
+                    <c:v>FY20</c:v>
                   </c:pt>
                   <c:pt idx="1">
-                    <c:v>2026f (IMF)</c:v>
+                    <c:v>FY21</c:v>
                   </c:pt>
                   <c:pt idx="2">
-                    <c:v>2026 Target (Govt.)</c:v>
+                    <c:v>FY22</c:v>
+                  </c:pt>
+                  <c:pt idx="3">
+                    <c:v>FY23</c:v>
+                  </c:pt>
+                  <c:pt idx="4">
+                    <c:v>FY24</c:v>
+                  </c:pt>
+                  <c:pt idx="5">
+                    <c:v>FY25</c:v>
+                  </c:pt>
+                  <c:pt idx="6">
+                    <c:v>FY26 Tgt.</c:v>
                   </c:pt>
                 </c:lvl>
               </c:multiLvlStrCache>
@@ -219,31 +275,43 @@
           </c:cat>
           <c:val>
             <c:numRef>
-              <c:f>Sheet1!$B$2:$B$4</c:f>
+              <c:f>Sheet1!$B$2:$B$8</c:f>
               <c:numCache>
                 <c:formatCode>General</c:formatCode>
-                <c:ptCount val="3"/>
+                <c:ptCount val="7"/>
                 <c:pt idx="0">
-                  <c:v>5.5</c:v>
+                  <c:v>-11.5</c:v>
                 </c:pt>
                 <c:pt idx="1">
-                  <c:v>4.6</c:v>
+                  <c:v>-7.8</c:v>
                 </c:pt>
                 <c:pt idx="2">
-                  <c:v>2.2</c:v>
+                  <c:v>0.7</c:v>
+                </c:pt>
+                <c:pt idx="3">
+                  <c:v>-1.8</c:v>
+                </c:pt>
+                <c:pt idx="4">
+                  <c:v>-5.3</c:v>
+                </c:pt>
+                <c:pt idx="5">
+                  <c:v>-4.6</c:v>
+                </c:pt>
+                <c:pt idx="6">
+                  <c:v>-2.2</c:v>
                 </c:pt>
               </c:numCache>
             </c:numRef>
           </c:val>
         </c:ser>
         <c:dLbls>
-          <c:numFmt formatCode="0.0" sourceLinked="0"/>
+          <c:numFmt formatCode="+0.0;-0.0;0.0" sourceLinked="0"/>
           <c:txPr>
             <a:bodyPr/>
             <a:lstStyle/>
             <a:p>
               <a:pPr>
-                <a:defRPr b="0" i="0" strike="noStrike" sz="1000" u="none">
+                <a:defRPr b="0" i="0" strike="noStrike" sz="900" u="none">
                   <a:solidFill>
                     <a:srgbClr val="263447"/>
                   </a:solidFill>
@@ -260,7 +328,7 @@
           <c:showBubbleSize val="0"/>
           <c:showLeaderLines val="0"/>
         </c:dLbls>
-        <c:gapWidth val="40"/>
+        <c:gapWidth val="30"/>
         <c:overlap val="0"/>
         <c:axId val="2094734554"/>
         <c:axId val="2094734552"/>
@@ -289,7 +357,7 @@
           <a:lstStyle/>
           <a:p>
             <a:pPr>
-              <a:defRPr sz="950" b="0" i="0" u="none" strike="noStrike">
+              <a:defRPr sz="900" b="0" i="0" u="none" strike="noStrike">
                 <a:solidFill>
                   <a:srgbClr val="6B7787"/>
                 </a:solidFill>
@@ -309,8 +377,8 @@
         <c:axId val="2094734552"/>
         <c:scaling>
           <c:orientation val="minMax"/>
-          <c:max val="7"/>
-          <c:min val="0"/>
+          <c:max val="3"/>
+          <c:min val="-13"/>
         </c:scaling>
         <c:delete val="1"/>
         <c:axPos val="l"/>
@@ -1980,7 +2048,7 @@
                 <a:ea typeface="Calibri" pitchFamily="34" charset="-122"/>
                 <a:cs typeface="Calibri" pitchFamily="34" charset="-120"/>
               </a:rPr>
-              <a:t>2026 Fiscal Deficit, % of GDP (IMF)</a:t>
+              <a:t>FY2025 Fiscal Deficit, % GDP (Actual)</a:t>
             </a:r>
             <a:endParaRPr lang="en-US" sz="900" dirty="0"/>
           </a:p>
@@ -2478,7 +2546,7 @@
                 <a:ea typeface="Calibri" pitchFamily="34" charset="-122"/>
                 <a:cs typeface="Calibri" pitchFamily="34" charset="-120"/>
               </a:rPr>
-              <a:t>Fiscal deficit narrowing: 5.5% → 4.6% of GDP (2026f, IMF); government’s own budget target is a tighter 2.2%</a:t>
+              <a:t>Fiscal deficit narrowing: -11.5% (FY2020) to -4.6% (FY2025, actual — Central Bank of T&amp;T); FY2026 government budget targets a tighter -2.2%</a:t>
             </a:r>
             <a:endParaRPr lang="en-US" sz="1050" dirty="0"/>
           </a:p>
@@ -2967,7 +3035,7 @@
                 <a:ea typeface="Calibri" pitchFamily="34" charset="-122"/>
                 <a:cs typeface="Calibri" pitchFamily="34" charset="-120"/>
               </a:rPr>
-              <a:t>Sources: IMF, Trinidad and Tobago — 2026 Article IV Consultation (Staff Concluding Statement, Feb 2026) and Country Report No. 26/121, Selected Issues (June 2026); S&amp;P Global Ratings sovereign rating actions (2025–26); T&amp;T Ministry of Energy and Energy Industries.</a:t>
+              <a:t>Sources: IMF, Trinidad and Tobago — 2026 Article IV Consultation (Staff Concluding Statement, Feb 2026) and Country Report No. 26/121, Selected Issues (June 2026); Central Bank of Trinidad and Tobago, Fiscal Balances and Ratios (Fiscal Year); S&amp;P Global Ratings sovereign rating actions (2025–26); T&amp;T Ministry of Energy and Energy Industries.</a:t>
             </a:r>
             <a:endParaRPr lang="en-US" sz="800" dirty="0"/>
           </a:p>
@@ -3374,7 +3442,7 @@
                 <a:ea typeface="Calibri" pitchFamily="34" charset="-122"/>
                 <a:cs typeface="Calibri" pitchFamily="34" charset="-120"/>
               </a:rPr>
-              <a:t>2026 Fiscal Deficit — down from 5.5%</a:t>
+              <a:t>FY2025 Fiscal Deficit (Actual) — down from 11.5% in FY2020</a:t>
             </a:r>
             <a:endParaRPr lang="en-US" sz="900" dirty="0"/>
           </a:p>
@@ -4003,7 +4071,7 @@
                 <a:ea typeface="Calibri" pitchFamily="34" charset="-122"/>
                 <a:cs typeface="Calibri" pitchFamily="34" charset="-120"/>
               </a:rPr>
-              <a:t>Debt stock still elevated at ~68% of GDP (end-2025) vs. ~27% in 2005 (avg. ~43% over 1990–2008) — the flow is improving before the stock stabilizes</a:t>
+              <a:t>FY2022’s swing to surplus (+0.7%) reflects an energy-price windfall, not a structural shift; debt stock remains elevated at ~68% of GDP (end-2025) vs. ~27% in 2005</a:t>
             </a:r>
             <a:endParaRPr lang="en-US" sz="850" dirty="0"/>
           </a:p>
@@ -4180,7 +4248,7 @@
                 <a:ea typeface="Calibri" pitchFamily="34" charset="-122"/>
                 <a:cs typeface="Calibri" pitchFamily="34" charset="-120"/>
               </a:rPr>
-              <a:t>Sources: IMF Country Report No. 26/121, Selected Issues (June 2026) — Fiscal Developments and Sovereign Wealth Fund Assets 2024 (orig. Sovereign Wealth Fund Institute &amp; IMF staff calcs.); IMF 2026 Article IV Consultation; T&amp;T Ministry of Finance, Budget Statement FY2026 (Oct 2025); Wood Mackenzie production data (chart to be inserted).</a:t>
+              <a:t>Sources: Central Bank of Trinidad and Tobago, Fiscal Balances and Ratios (Fiscal Year) — FY2020–FY2025 actuals; T&amp;T Ministry of Finance, Budget Statement FY2026 (Oct 2025) — FY2026 target; IMF Country Report No. 26/121, Selected Issues (June 2026) — public debt and Sovereign Wealth Fund Assets 2024 (orig. Sovereign Wealth Fund Institute &amp; IMF staff calcs.); Energy Institute / Wood Mackenzie production data (chart to be inserted).</a:t>
             </a:r>
             <a:endParaRPr lang="en-US" sz="800" dirty="0"/>
           </a:p>

</xml_diff>

<commit_message>
Use signed fiscal balance convention consistently across both slides
Negative = deficit, positive = surplus, everywhere (stat cards,
bullets, chart), matching the Central Bank/IMF source convention and
removing the prior inconsistency where stat cards showed a positive
magnitude labeled "Fiscal Deficit" while the chart showed signed
values. Relabeled "Fiscal Deficit" to "Fiscal Balance" throughout
since the term is no longer sign-specific.
</commit_message>
<xml_diff>
--- a/trinidad-tobago-macro-outlook/Trinidad_Tobago_Macro_Outlook_Power_Sector.pptx
+++ b/trinidad-tobago-macro-outlook/Trinidad_Tobago_Macro_Outlook_Power_Sector.pptx
@@ -2009,7 +2009,7 @@
                 <a:ea typeface="Calibri" pitchFamily="34" charset="-122"/>
                 <a:cs typeface="Calibri" pitchFamily="34" charset="-120"/>
               </a:rPr>
-              <a:t>4.6%</a:t>
+              <a:t>-4.6%</a:t>
             </a:r>
             <a:endParaRPr lang="en-US" sz="2100" dirty="0"/>
           </a:p>
@@ -2048,7 +2048,7 @@
                 <a:ea typeface="Calibri" pitchFamily="34" charset="-122"/>
                 <a:cs typeface="Calibri" pitchFamily="34" charset="-120"/>
               </a:rPr>
-              <a:t>FY2025 Fiscal Deficit, % GDP (Actual)</a:t>
+              <a:t>FY2025 Fiscal Balance, % GDP (Actual)</a:t>
             </a:r>
             <a:endParaRPr lang="en-US" sz="900" dirty="0"/>
           </a:p>
@@ -2546,7 +2546,7 @@
                 <a:ea typeface="Calibri" pitchFamily="34" charset="-122"/>
                 <a:cs typeface="Calibri" pitchFamily="34" charset="-120"/>
               </a:rPr>
-              <a:t>Fiscal deficit narrowing: -11.5% (FY2020) to -4.6% (FY2025, actual — Central Bank of T&amp;T); FY2026 government budget targets a tighter -2.2%</a:t>
+              <a:t>Fiscal balance improving: -11.5% of GDP (FY2020) to -4.6% (FY2025, actual — Central Bank of T&amp;T); FY2026 government budget targets -2.2%</a:t>
             </a:r>
             <a:endParaRPr lang="en-US" sz="1050" dirty="0"/>
           </a:p>
@@ -3403,7 +3403,7 @@
                 <a:ea typeface="Calibri" pitchFamily="34" charset="-122"/>
                 <a:cs typeface="Calibri" pitchFamily="34" charset="-120"/>
               </a:rPr>
-              <a:t>4.6%</a:t>
+              <a:t>-4.6%</a:t>
             </a:r>
             <a:endParaRPr lang="en-US" sz="2100" dirty="0"/>
           </a:p>
@@ -3442,7 +3442,7 @@
                 <a:ea typeface="Calibri" pitchFamily="34" charset="-122"/>
                 <a:cs typeface="Calibri" pitchFamily="34" charset="-120"/>
               </a:rPr>
-              <a:t>FY2025 Fiscal Deficit (Actual) — down from 11.5% in FY2020</a:t>
+              <a:t>FY2025 Fiscal Balance (Actual) — improved from -11.5% in FY2020</a:t>
             </a:r>
             <a:endParaRPr lang="en-US" sz="900" dirty="0"/>
           </a:p>
@@ -4016,7 +4016,7 @@
                 <a:ea typeface="Calibri" pitchFamily="34" charset="-122"/>
                 <a:cs typeface="Calibri" pitchFamily="34" charset="-120"/>
               </a:rPr>
-              <a:t>Fiscal Deficit: Narrowing, Not Yet Closed</a:t>
+              <a:t>Fiscal Balance: Narrowing, Not Yet Closed</a:t>
             </a:r>
             <a:endParaRPr lang="en-US" sz="1300" dirty="0"/>
           </a:p>

</xml_diff>